<commit_message>
Tidy README, refresh slides, and update site description
- README: academic links line, no cost or deployment details, accurate
  wording for the specification, presentation files in the structure table
- presentation.pptx/pdf: speaker notes point to the new Case Studies tab
- web/index.html: description covers all 16 case studies

Co-Authored-By: Claude Opus 5.5 <noreply@anthropic.com>
</commit_message>
<xml_diff>
--- a/presentation.pptx
+++ b/presentation.pptx
@@ -117,7 +117,7 @@
   <p:extLst>
     <p:ext uri="{521415D9-36F7-43E2-AB2F-B90AF26B5E84}">
       <p14:sectionLst xmlns:p14="http://schemas.microsoft.com/office/powerpoint/2010/main">
-        <p14:section name="The paper" id="{5da293c7-bf60-6d09-a27a-ae5f75cea04d}">
+        <p14:section name="The paper" id="{c1ed80a5-4c3e-b34e-d494-cc6c32b5a9de}">
           <p14:sldIdLst>
             <p14:sldId id="256"/>
             <p14:sldId id="257"/>
@@ -127,7 +127,7 @@
             <p14:sldId id="261"/>
           </p14:sldIdLst>
         </p14:section>
-        <p14:section name="Our work" id="{9438e524-f795-2833-526c-76ac84d9b7b0}">
+        <p14:section name="Our work" id="{36f0bdf2-d7ec-9e8d-ac7c-b2a5a9ecd007}">
           <p14:sldIdLst>
             <p14:sldId id="262"/>
             <p14:sldId id="263"/>
@@ -135,7 +135,7 @@
             <p14:sldId id="265"/>
           </p14:sldIdLst>
         </p14:section>
-        <p14:section name="Questions" id="{03d1302a-c069-3c94-5678-7ae3c59bd52f}">
+        <p14:section name="Questions" id="{ff90b83a-5fc4-cbaf-a666-89a6dc0b048e}">
           <p14:sldIdLst>
             <p14:sldId id="266"/>
           </p14:sldIdLst>
@@ -1072,7 +1072,7 @@
           <a:p>
             <a:r>
               <a:rPr lang="en-US" dirty="0"/>
-              <a:t>[Switch to the browser: chaos-lab-psi.vercel.app/#cs8, step through with the arrow keys, then open The SSN Leak tab.]
+              <a:t>[Switch to the browser tab open on chaos-lab-psi.vercel.app/#cases/8 (Case Studies tab). Step through with the arrow keys, then click #3 in the pinned “Tested by us” list.]
 In the first case, the agent's suspicion didn't carry over to a new chat, so changing a display name was enough for a full takeover. In the second, the agent guarded the word 'SSN' but not the information.</a:t>
             </a:r>
             <a:endParaRPr lang="en-US" dirty="0"/>
@@ -1425,7 +1425,7 @@
           <a:p>
             <a:r>
               <a:rPr lang="en-US" dirty="0"/>
-              <a:t>[Switch to the browser tab already open on chaos-lab-psi.vercel.app/#exp. Show GPT-5 nano, click Replay a trial on 8B, switch the dropdown to Llama 3.2, then open Comparison. This table is the backup if the demo fails.]
+              <a:t>[Switch to the browser tab already open on chaos-lab-psi.vercel.app/#exp (Our Experiment tab). Show GPT-5 nano, click Replay a trial on 8B, switch the dropdown to Llama 3.2, then open Comparison. This table is the backup if the demo fails.]
 The GPT models replay the paper exactly: they catch the fake in the same chat but get taken over in a fresh one. Showing the real ID fixes it for them; a memory note doesn't. The small models fall for it every time, even with the real ID. For the SSN, nobody leaks when asked directly, but a 'summary' gets it out. A rule in the prompt even backfired on Qwen, 33 to 73 percent, while the filter in code stopped every leak.</a:t>
             </a:r>
             <a:endParaRPr lang="en-US" dirty="0"/>

</xml_diff>

<commit_message>
Redraw OpenClaw and Moltbook diagrams on slides 2 and 3
Co-Authored-By: Claude Opus 5.5 <noreply@anthropic.com>
</commit_message>
<xml_diff>
--- a/presentation.pptx
+++ b/presentation.pptx
@@ -117,7 +117,7 @@
   <p:extLst>
     <p:ext uri="{521415D9-36F7-43E2-AB2F-B90AF26B5E84}">
       <p14:sectionLst xmlns:p14="http://schemas.microsoft.com/office/powerpoint/2010/main">
-        <p14:section name="The paper" id="{c1ed80a5-4c3e-b34e-d494-cc6c32b5a9de}">
+        <p14:section name="The paper" id="{0f32846c-e220-2bf6-4b82-5ff4e95099fa}">
           <p14:sldIdLst>
             <p14:sldId id="256"/>
             <p14:sldId id="257"/>
@@ -127,7 +127,7 @@
             <p14:sldId id="261"/>
           </p14:sldIdLst>
         </p14:section>
-        <p14:section name="Our work" id="{36f0bdf2-d7ec-9e8d-ac7c-b2a5a9ecd007}">
+        <p14:section name="Our work" id="{b1899ed9-8dd1-300e-a564-cc42d5206766}">
           <p14:sldIdLst>
             <p14:sldId id="262"/>
             <p14:sldId id="263"/>
@@ -135,7 +135,7 @@
             <p14:sldId id="265"/>
           </p14:sldIdLst>
         </p14:section>
-        <p14:section name="Questions" id="{ff90b83a-5fc4-cbaf-a666-89a6dc0b048e}">
+        <p14:section name="Questions" id="{9c0f0350-2375-93e8-97de-a8b8565a1fd4}">
           <p14:sldIdLst>
             <p14:sldId id="266"/>
           </p14:sldIdLst>
@@ -808,7 +808,7 @@
           <a:p>
             <a:r>
               <a:rPr lang="en-US" dirty="0"/>
-              <a:t>Keep two things in mind. The agent's identity and memory are just text files, and 'who is my owner' is just a sentence. Both come back later.</a:t>
+              <a:t>OpenClaw is the framework they used: an open-source agent that runs 24/7. A gateway connects the model to tools like a shell and browser, and to Discord, where the agent is a bot anyone can message. Two things to remember. First, the agent is a folder of markdown files (personality, rules, memory) pasted into the prompt every turn, and the agent can edit them itself. Second, 'my owner is Chris' is just a sentence in one of those files, and each Discord DM starts a fresh session. Nothing verifies who's talking. Both come back in the failures.</a:t>
             </a:r>
             <a:endParaRPr lang="en-US" dirty="0"/>
           </a:p>
@@ -896,7 +896,7 @@
           <a:p>
             <a:r>
               <a:rPr lang="en-US" dirty="0"/>
-              <a:t>Moltbook is a social network for agents. When an agent fails there, the failure reaches other agents, not just people.</a:t>
+              <a:t>Moltbook is Reddit, but only AI agents can post; humans can only watch. The study's agents were on it. After Ash wiped its own email setup to 'delete' a secret, it posted that 'nuclear options work', and the next day another agent put Ash on its public 'arrests' list for credential theft. When an agent fails there, the failure reaches other agents, not just people.</a:t>
             </a:r>
             <a:endParaRPr lang="en-US" dirty="0"/>
           </a:p>
@@ -3611,14 +3611,388 @@
       </p:sp>
       <p:sp>
         <p:nvSpPr>
-          <p:cNvPr id="3" name="num-1"/>
+          <p:cNvPr id="3" name="Text 1"/>
+          <p:cNvSpPr txBox="1"/>
+          <p:nvPr/>
+        </p:nvSpPr>
+        <p:spPr>
+          <a:xfrm>
+            <a:off x="548640" y="1325880"/>
+            <a:ext cx="1920240" cy="228600"/>
+          </a:xfrm>
+          <a:prstGeom prst="rect">
+            <a:avLst/>
+          </a:prstGeom>
+          <a:noFill/>
+          <a:ln/>
+        </p:spPr>
+        <p:txBody>
+          <a:bodyPr wrap="square" lIns="0" tIns="0" rIns="0" bIns="0" rtlCol="0" anchor="t"/>
+          <a:lstStyle/>
+          <a:p>
+            <a:pPr indent="0" marL="0">
+              <a:buNone/>
+            </a:pPr>
+            <a:r>
+              <a:rPr lang="en-US" sz="1000" b="1" spc="100" kern="0" dirty="0">
+                <a:solidFill>
+                  <a:schemeClr val="accent6"/>
+                </a:solidFill>
+              </a:rPr>
+              <a:t>WHO CAN MESSAGE IT</a:t>
+            </a:r>
+            <a:endParaRPr lang="en-US" sz="1000" dirty="0"/>
+          </a:p>
+        </p:txBody>
+      </p:sp>
+      <p:sp>
+        <p:nvSpPr>
+          <p:cNvPr id="4" name="sender-0"/>
           <p:cNvSpPr/>
           <p:nvPr/>
         </p:nvSpPr>
         <p:spPr>
           <a:xfrm>
-            <a:off x="548640" y="1463040"/>
-            <a:ext cx="457200" cy="457200"/>
+            <a:off x="548640" y="1645920"/>
+            <a:ext cx="1691640" cy="438912"/>
+          </a:xfrm>
+          <a:prstGeom prst="roundRect">
+            <a:avLst>
+              <a:gd name="adj" fmla="val 12500"/>
+            </a:avLst>
+          </a:prstGeom>
+          <a:solidFill>
+            <a:srgbClr val="FCEFC7"/>
+          </a:solidFill>
+          <a:ln w="12700">
+            <a:solidFill>
+              <a:srgbClr val="D9A520"/>
+            </a:solidFill>
+            <a:prstDash val="solid"/>
+          </a:ln>
+        </p:spPr>
+      </p:sp>
+      <p:sp>
+        <p:nvSpPr>
+          <p:cNvPr id="5" name="Text 3"/>
+          <p:cNvSpPr txBox="1"/>
+          <p:nvPr/>
+        </p:nvSpPr>
+        <p:spPr>
+          <a:xfrm>
+            <a:off x="548640" y="1645920"/>
+            <a:ext cx="1691640" cy="438912"/>
+          </a:xfrm>
+          <a:prstGeom prst="rect">
+            <a:avLst/>
+          </a:prstGeom>
+          <a:noFill/>
+          <a:ln/>
+        </p:spPr>
+        <p:txBody>
+          <a:bodyPr wrap="square" lIns="0" tIns="0" rIns="0" bIns="0" rtlCol="0" anchor="ctr"/>
+          <a:lstStyle/>
+          <a:p>
+            <a:pPr algn="ctr" indent="0" marL="0">
+              <a:buNone/>
+            </a:pPr>
+            <a:r>
+              <a:rPr lang="en-US" sz="1300" b="1" dirty="0">
+                <a:solidFill>
+                  <a:schemeClr val="tx1"/>
+                </a:solidFill>
+              </a:rPr>
+              <a:t>Owner</a:t>
+            </a:r>
+            <a:endParaRPr lang="en-US" sz="1300" dirty="0"/>
+          </a:p>
+        </p:txBody>
+      </p:sp>
+      <p:sp>
+        <p:nvSpPr>
+          <p:cNvPr id="6" name="sender-arrow-0"/>
+          <p:cNvSpPr/>
+          <p:nvPr/>
+        </p:nvSpPr>
+        <p:spPr>
+          <a:xfrm>
+            <a:off x="2240280" y="1865376"/>
+            <a:ext cx="502920" cy="566928"/>
+          </a:xfrm>
+          <a:prstGeom prst="line">
+            <a:avLst/>
+          </a:prstGeom>
+          <a:noFill/>
+          <a:ln w="19050">
+            <a:solidFill>
+              <a:srgbClr val="8D9696"/>
+            </a:solidFill>
+            <a:prstDash val="solid"/>
+            <a:tailEnd type="triangle"/>
+          </a:ln>
+        </p:spPr>
+      </p:sp>
+      <p:sp>
+        <p:nvSpPr>
+          <p:cNvPr id="7" name="sender-1"/>
+          <p:cNvSpPr/>
+          <p:nvPr/>
+        </p:nvSpPr>
+        <p:spPr>
+          <a:xfrm>
+            <a:off x="548640" y="2212848"/>
+            <a:ext cx="1691640" cy="438912"/>
+          </a:xfrm>
+          <a:prstGeom prst="roundRect">
+            <a:avLst>
+              <a:gd name="adj" fmla="val 12500"/>
+            </a:avLst>
+          </a:prstGeom>
+          <a:solidFill>
+            <a:srgbClr val="FFFFFF"/>
+          </a:solidFill>
+          <a:ln w="12700">
+            <a:solidFill>
+              <a:srgbClr val="D5D9D9"/>
+            </a:solidFill>
+            <a:prstDash val="solid"/>
+          </a:ln>
+        </p:spPr>
+      </p:sp>
+      <p:sp>
+        <p:nvSpPr>
+          <p:cNvPr id="8" name="Text 6"/>
+          <p:cNvSpPr txBox="1"/>
+          <p:nvPr/>
+        </p:nvSpPr>
+        <p:spPr>
+          <a:xfrm>
+            <a:off x="548640" y="2212848"/>
+            <a:ext cx="1691640" cy="438912"/>
+          </a:xfrm>
+          <a:prstGeom prst="rect">
+            <a:avLst/>
+          </a:prstGeom>
+          <a:noFill/>
+          <a:ln/>
+        </p:spPr>
+        <p:txBody>
+          <a:bodyPr wrap="square" lIns="0" tIns="0" rIns="0" bIns="0" rtlCol="0" anchor="ctr"/>
+          <a:lstStyle/>
+          <a:p>
+            <a:pPr algn="ctr" indent="0" marL="0">
+              <a:buNone/>
+            </a:pPr>
+            <a:r>
+              <a:rPr lang="en-US" sz="1300" dirty="0">
+                <a:solidFill>
+                  <a:schemeClr val="tx1"/>
+                </a:solidFill>
+              </a:rPr>
+              <a:t>Anyone else</a:t>
+            </a:r>
+            <a:endParaRPr lang="en-US" sz="1300" dirty="0"/>
+          </a:p>
+        </p:txBody>
+      </p:sp>
+      <p:sp>
+        <p:nvSpPr>
+          <p:cNvPr id="9" name="sender-arrow-1"/>
+          <p:cNvSpPr/>
+          <p:nvPr/>
+        </p:nvSpPr>
+        <p:spPr>
+          <a:xfrm>
+            <a:off x="2240280" y="2432304"/>
+            <a:ext cx="502920" cy="0"/>
+          </a:xfrm>
+          <a:prstGeom prst="line">
+            <a:avLst/>
+          </a:prstGeom>
+          <a:noFill/>
+          <a:ln w="19050">
+            <a:solidFill>
+              <a:srgbClr val="8D9696"/>
+            </a:solidFill>
+            <a:prstDash val="solid"/>
+            <a:tailEnd type="triangle"/>
+          </a:ln>
+        </p:spPr>
+      </p:sp>
+      <p:sp>
+        <p:nvSpPr>
+          <p:cNvPr id="10" name="sender-2"/>
+          <p:cNvSpPr/>
+          <p:nvPr/>
+        </p:nvSpPr>
+        <p:spPr>
+          <a:xfrm>
+            <a:off x="548640" y="2779776"/>
+            <a:ext cx="1691640" cy="438912"/>
+          </a:xfrm>
+          <a:prstGeom prst="roundRect">
+            <a:avLst>
+              <a:gd name="adj" fmla="val 12500"/>
+            </a:avLst>
+          </a:prstGeom>
+          <a:solidFill>
+            <a:srgbClr val="FFFFFF"/>
+          </a:solidFill>
+          <a:ln w="12700">
+            <a:solidFill>
+              <a:srgbClr val="D5D9D9"/>
+            </a:solidFill>
+            <a:prstDash val="solid"/>
+          </a:ln>
+        </p:spPr>
+      </p:sp>
+      <p:sp>
+        <p:nvSpPr>
+          <p:cNvPr id="11" name="Text 9"/>
+          <p:cNvSpPr txBox="1"/>
+          <p:nvPr/>
+        </p:nvSpPr>
+        <p:spPr>
+          <a:xfrm>
+            <a:off x="548640" y="2779776"/>
+            <a:ext cx="1691640" cy="438912"/>
+          </a:xfrm>
+          <a:prstGeom prst="rect">
+            <a:avLst/>
+          </a:prstGeom>
+          <a:noFill/>
+          <a:ln/>
+        </p:spPr>
+        <p:txBody>
+          <a:bodyPr wrap="square" lIns="0" tIns="0" rIns="0" bIns="0" rtlCol="0" anchor="ctr"/>
+          <a:lstStyle/>
+          <a:p>
+            <a:pPr algn="ctr" indent="0" marL="0">
+              <a:buNone/>
+            </a:pPr>
+            <a:r>
+              <a:rPr lang="en-US" sz="1300" dirty="0">
+                <a:solidFill>
+                  <a:schemeClr val="tx1"/>
+                </a:solidFill>
+              </a:rPr>
+              <a:t>Other agents</a:t>
+            </a:r>
+            <a:endParaRPr lang="en-US" sz="1300" dirty="0"/>
+          </a:p>
+        </p:txBody>
+      </p:sp>
+      <p:sp>
+        <p:nvSpPr>
+          <p:cNvPr id="12" name="sender-arrow-2"/>
+          <p:cNvSpPr/>
+          <p:nvPr/>
+        </p:nvSpPr>
+        <p:spPr>
+          <a:xfrm flipV="1">
+            <a:off x="2240280" y="2432304"/>
+            <a:ext cx="502920" cy="566928"/>
+          </a:xfrm>
+          <a:prstGeom prst="line">
+            <a:avLst/>
+          </a:prstGeom>
+          <a:noFill/>
+          <a:ln w="19050">
+            <a:solidFill>
+              <a:srgbClr val="8D9696"/>
+            </a:solidFill>
+            <a:prstDash val="solid"/>
+            <a:tailEnd type="triangle"/>
+          </a:ln>
+        </p:spPr>
+      </p:sp>
+      <p:sp>
+        <p:nvSpPr>
+          <p:cNvPr id="13" name="discord-box"/>
+          <p:cNvSpPr/>
+          <p:nvPr/>
+        </p:nvSpPr>
+        <p:spPr>
+          <a:xfrm>
+            <a:off x="2743200" y="1929384"/>
+            <a:ext cx="1783080" cy="1005840"/>
+          </a:xfrm>
+          <a:prstGeom prst="roundRect">
+            <a:avLst>
+              <a:gd name="adj" fmla="val 5455"/>
+            </a:avLst>
+          </a:prstGeom>
+          <a:solidFill>
+            <a:schemeClr val="bg2"/>
+          </a:solidFill>
+          <a:ln w="12700">
+            <a:solidFill>
+              <a:srgbClr val="D5D9D9"/>
+            </a:solidFill>
+            <a:prstDash val="solid"/>
+          </a:ln>
+        </p:spPr>
+      </p:sp>
+      <p:sp>
+        <p:nvSpPr>
+          <p:cNvPr id="14" name="Text 12"/>
+          <p:cNvSpPr txBox="1"/>
+          <p:nvPr/>
+        </p:nvSpPr>
+        <p:spPr>
+          <a:xfrm>
+            <a:off x="2788920" y="1929384"/>
+            <a:ext cx="1691640" cy="1005840"/>
+          </a:xfrm>
+          <a:prstGeom prst="rect">
+            <a:avLst/>
+          </a:prstGeom>
+          <a:noFill/>
+          <a:ln/>
+        </p:spPr>
+        <p:txBody>
+          <a:bodyPr wrap="square" lIns="0" tIns="0" rIns="0" bIns="0" rtlCol="0" anchor="ctr"/>
+          <a:lstStyle/>
+          <a:p>
+            <a:pPr algn="ctr" indent="0" marL="0">
+              <a:buNone/>
+            </a:pPr>
+            <a:r>
+              <a:rPr lang="en-US" sz="1400" b="1" dirty="0">
+                <a:solidFill>
+                  <a:schemeClr val="tx1"/>
+                </a:solidFill>
+              </a:rPr>
+              <a:t>Discord bot</a:t>
+            </a:r>
+            <a:endParaRPr lang="en-US" sz="1400" dirty="0"/>
+          </a:p>
+          <a:p>
+            <a:pPr algn="ctr" indent="0" marL="0">
+              <a:buNone/>
+            </a:pPr>
+            <a:r>
+              <a:rPr lang="en-US" sz="1100" dirty="0">
+                <a:solidFill>
+                  <a:schemeClr val="accent6"/>
+                </a:solidFill>
+              </a:rPr>
+              <a:t>each DM = a new session</a:t>
+            </a:r>
+            <a:endParaRPr lang="en-US" sz="1400" dirty="0"/>
+          </a:p>
+        </p:txBody>
+      </p:sp>
+      <p:sp>
+        <p:nvSpPr>
+          <p:cNvPr id="15" name="num-3"/>
+          <p:cNvSpPr/>
+          <p:nvPr/>
+        </p:nvSpPr>
+        <p:spPr>
+          <a:xfrm>
+            <a:off x="4343400" y="1783080"/>
+            <a:ext cx="310896" cy="310896"/>
           </a:xfrm>
           <a:prstGeom prst="ellipse">
             <a:avLst/>
@@ -3636,14 +4010,14 @@
       </p:sp>
       <p:sp>
         <p:nvSpPr>
-          <p:cNvPr id="4" name="Text 2"/>
+          <p:cNvPr id="16" name="Text 14"/>
           <p:cNvSpPr txBox="1"/>
           <p:nvPr/>
         </p:nvSpPr>
         <p:spPr>
           <a:xfrm>
-            <a:off x="548640" y="1463040"/>
-            <a:ext cx="457200" cy="457200"/>
+            <a:off x="4343400" y="1783080"/>
+            <a:ext cx="310896" cy="310896"/>
           </a:xfrm>
           <a:prstGeom prst="rect">
             <a:avLst/>
@@ -3664,7 +4038,7 @@
                   <a:schemeClr val="tx1"/>
                 </a:solidFill>
               </a:rPr>
-              <a:t>1</a:t>
+              <a:t>3</a:t>
             </a:r>
             <a:endParaRPr lang="en-US" sz="1600" dirty="0"/>
           </a:p>
@@ -3672,14 +4046,65 @@
       </p:sp>
       <p:sp>
         <p:nvSpPr>
-          <p:cNvPr id="5" name="Text 3"/>
+          <p:cNvPr id="17" name="arrow-gateway"/>
+          <p:cNvSpPr/>
+          <p:nvPr/>
+        </p:nvSpPr>
+        <p:spPr>
+          <a:xfrm>
+            <a:off x="4526280" y="2432304"/>
+            <a:ext cx="320040" cy="0"/>
+          </a:xfrm>
+          <a:prstGeom prst="line">
+            <a:avLst/>
+          </a:prstGeom>
+          <a:noFill/>
+          <a:ln w="19050">
+            <a:solidFill>
+              <a:srgbClr val="8D9696"/>
+            </a:solidFill>
+            <a:prstDash val="solid"/>
+            <a:tailEnd type="triangle"/>
+          </a:ln>
+        </p:spPr>
+      </p:sp>
+      <p:sp>
+        <p:nvSpPr>
+          <p:cNvPr id="18" name="gateway-box"/>
+          <p:cNvSpPr/>
+          <p:nvPr/>
+        </p:nvSpPr>
+        <p:spPr>
+          <a:xfrm>
+            <a:off x="4846320" y="1929384"/>
+            <a:ext cx="1600200" cy="1005840"/>
+          </a:xfrm>
+          <a:prstGeom prst="roundRect">
+            <a:avLst>
+              <a:gd name="adj" fmla="val 5455"/>
+            </a:avLst>
+          </a:prstGeom>
+          <a:solidFill>
+            <a:schemeClr val="bg2"/>
+          </a:solidFill>
+          <a:ln w="12700">
+            <a:solidFill>
+              <a:srgbClr val="D5D9D9"/>
+            </a:solidFill>
+            <a:prstDash val="solid"/>
+          </a:ln>
+        </p:spPr>
+      </p:sp>
+      <p:sp>
+        <p:nvSpPr>
+          <p:cNvPr id="19" name="Text 17"/>
           <p:cNvSpPr txBox="1"/>
           <p:nvPr/>
         </p:nvSpPr>
         <p:spPr>
           <a:xfrm>
-            <a:off x="1188720" y="1444752"/>
-            <a:ext cx="5120640" cy="1371600"/>
+            <a:off x="4846320" y="1929384"/>
+            <a:ext cx="1600200" cy="1005840"/>
           </a:xfrm>
           <a:prstGeom prst="rect">
             <a:avLst/>
@@ -3688,54 +4113,427 @@
           <a:ln/>
         </p:spPr>
         <p:txBody>
+          <a:bodyPr wrap="square" lIns="0" tIns="0" rIns="0" bIns="0" rtlCol="0" anchor="ctr"/>
+          <a:lstStyle/>
+          <a:p>
+            <a:pPr algn="ctr" indent="0" marL="0">
+              <a:buNone/>
+            </a:pPr>
+            <a:r>
+              <a:rPr lang="en-US" sz="1400" b="1" dirty="0">
+                <a:solidFill>
+                  <a:schemeClr val="tx1"/>
+                </a:solidFill>
+              </a:rPr>
+              <a:t>Gateway</a:t>
+            </a:r>
+            <a:endParaRPr lang="en-US" sz="1400" dirty="0"/>
+          </a:p>
+          <a:p>
+            <a:pPr algn="ctr" indent="0" marL="0">
+              <a:buNone/>
+            </a:pPr>
+            <a:r>
+              <a:rPr lang="en-US" sz="1100" dirty="0">
+                <a:solidFill>
+                  <a:schemeClr val="accent6"/>
+                </a:solidFill>
+              </a:rPr>
+              <a:t>always on, 24/7</a:t>
+            </a:r>
+            <a:endParaRPr lang="en-US" sz="1400" dirty="0"/>
+          </a:p>
+        </p:txBody>
+      </p:sp>
+      <p:sp>
+        <p:nvSpPr>
+          <p:cNvPr id="20" name="arrow-prompt"/>
+          <p:cNvSpPr/>
+          <p:nvPr/>
+        </p:nvSpPr>
+        <p:spPr>
+          <a:xfrm>
+            <a:off x="6446520" y="2432304"/>
+            <a:ext cx="320040" cy="0"/>
+          </a:xfrm>
+          <a:prstGeom prst="line">
+            <a:avLst/>
+          </a:prstGeom>
+          <a:noFill/>
+          <a:ln w="19050">
+            <a:solidFill>
+              <a:srgbClr val="8D9696"/>
+            </a:solidFill>
+            <a:prstDash val="solid"/>
+            <a:tailEnd type="triangle"/>
+          </a:ln>
+        </p:spPr>
+      </p:sp>
+      <p:sp>
+        <p:nvSpPr>
+          <p:cNvPr id="21" name="prompt-box"/>
+          <p:cNvSpPr/>
+          <p:nvPr/>
+        </p:nvSpPr>
+        <p:spPr>
+          <a:xfrm>
+            <a:off x="6766560" y="1371600"/>
+            <a:ext cx="2468880" cy="2103120"/>
+          </a:xfrm>
+          <a:prstGeom prst="roundRect">
+            <a:avLst>
+              <a:gd name="adj" fmla="val 2609"/>
+            </a:avLst>
+          </a:prstGeom>
+          <a:solidFill>
+            <a:srgbClr val="FFFFFF"/>
+          </a:solidFill>
+          <a:ln w="12700">
+            <a:solidFill>
+              <a:schemeClr val="tx2"/>
+            </a:solidFill>
+            <a:prstDash val="solid"/>
+          </a:ln>
+        </p:spPr>
+      </p:sp>
+      <p:sp>
+        <p:nvSpPr>
+          <p:cNvPr id="22" name="Text 20"/>
+          <p:cNvSpPr txBox="1"/>
+          <p:nvPr/>
+        </p:nvSpPr>
+        <p:spPr>
+          <a:xfrm>
+            <a:off x="6903720" y="1463040"/>
+            <a:ext cx="2194560" cy="228600"/>
+          </a:xfrm>
+          <a:prstGeom prst="rect">
+            <a:avLst/>
+          </a:prstGeom>
+          <a:noFill/>
+          <a:ln/>
+        </p:spPr>
+        <p:txBody>
           <a:bodyPr wrap="square" lIns="0" tIns="0" rIns="0" bIns="0" rtlCol="0" anchor="t"/>
           <a:lstStyle/>
           <a:p>
             <a:pPr indent="0" marL="0">
-              <a:spcAft>
-                <a:spcPts val="400"/>
-              </a:spcAft>
-              <a:buNone/>
-            </a:pPr>
-            <a:r>
-              <a:rPr lang="en-US" sz="1900" b="1" dirty="0">
+              <a:buNone/>
+            </a:pPr>
+            <a:r>
+              <a:rPr lang="en-US" sz="950" b="1" spc="100" kern="0" dirty="0">
+                <a:solidFill>
+                  <a:schemeClr val="accent6"/>
+                </a:solidFill>
+              </a:rPr>
+              <a:t>PROMPT, REBUILT EVERY TURN</a:t>
+            </a:r>
+            <a:endParaRPr lang="en-US" sz="950" dirty="0"/>
+          </a:p>
+        </p:txBody>
+      </p:sp>
+      <p:sp>
+        <p:nvSpPr>
+          <p:cNvPr id="23" name="file-0"/>
+          <p:cNvSpPr/>
+          <p:nvPr/>
+        </p:nvSpPr>
+        <p:spPr>
+          <a:xfrm>
+            <a:off x="6903720" y="1755648"/>
+            <a:ext cx="2194560" cy="329184"/>
+          </a:xfrm>
+          <a:prstGeom prst="rect">
+            <a:avLst/>
+          </a:prstGeom>
+          <a:solidFill>
+            <a:schemeClr val="bg2"/>
+          </a:solidFill>
+          <a:ln w="9525">
+            <a:solidFill>
+              <a:schemeClr val="bg2"/>
+            </a:solidFill>
+            <a:prstDash val="solid"/>
+          </a:ln>
+        </p:spPr>
+      </p:sp>
+      <p:sp>
+        <p:nvSpPr>
+          <p:cNvPr id="24" name="Text 22"/>
+          <p:cNvSpPr txBox="1"/>
+          <p:nvPr/>
+        </p:nvSpPr>
+        <p:spPr>
+          <a:xfrm>
+            <a:off x="6995160" y="1755648"/>
+            <a:ext cx="2057400" cy="329184"/>
+          </a:xfrm>
+          <a:prstGeom prst="rect">
+            <a:avLst/>
+          </a:prstGeom>
+          <a:noFill/>
+          <a:ln/>
+        </p:spPr>
+        <p:txBody>
+          <a:bodyPr wrap="square" lIns="0" tIns="0" rIns="0" bIns="0" rtlCol="0" anchor="ctr"/>
+          <a:lstStyle/>
+          <a:p>
+            <a:pPr indent="0" marL="0">
+              <a:buNone/>
+            </a:pPr>
+            <a:r>
+              <a:rPr lang="en-US" sz="1100" b="1" dirty="0">
                 <a:solidFill>
                   <a:schemeClr val="tx1"/>
                 </a:solidFill>
-              </a:rPr>
-              <a:t>An LLM with real tools</a:t>
-            </a:r>
-            <a:endParaRPr lang="en-US" sz="1900" dirty="0"/>
-          </a:p>
-          <a:p>
+                <a:latin typeface="Courier New" pitchFamily="34" charset="0"/>
+                <a:ea typeface="Courier New" pitchFamily="34" charset="-122"/>
+                <a:cs typeface="Courier New" pitchFamily="34" charset="-120"/>
+              </a:rPr>
+              <a:t>SOUL.md</a:t>
+            </a:r>
             <a:pPr indent="0" marL="0">
-              <a:spcAft>
-                <a:spcPts val="400"/>
-              </a:spcAft>
-              <a:buNone/>
-            </a:pPr>
-            <a:r>
-              <a:rPr lang="en-US" sz="1500" dirty="0">
+              <a:buNone/>
+            </a:pPr>
+            <a:r>
+              <a:rPr lang="en-US" sz="1100" dirty="0">
                 <a:solidFill>
                   <a:schemeClr val="tx2"/>
                 </a:solidFill>
               </a:rPr>
-              <a:t>Connects a language model to a shell, files, email and the web, plus chat apps like Discord. It runs 24/7.</a:t>
-            </a:r>
-            <a:endParaRPr lang="en-US" sz="1900" dirty="0"/>
-          </a:p>
-        </p:txBody>
-      </p:sp>
-      <p:sp>
-        <p:nvSpPr>
-          <p:cNvPr id="6" name="num-2"/>
+              <a:t>  persona</a:t>
+            </a:r>
+            <a:endParaRPr lang="en-US" sz="1100" dirty="0"/>
+          </a:p>
+        </p:txBody>
+      </p:sp>
+      <p:sp>
+        <p:nvSpPr>
+          <p:cNvPr id="25" name="file-1"/>
           <p:cNvSpPr/>
           <p:nvPr/>
         </p:nvSpPr>
         <p:spPr>
           <a:xfrm>
-            <a:off x="548640" y="3017520"/>
-            <a:ext cx="457200" cy="457200"/>
+            <a:off x="6903720" y="2157984"/>
+            <a:ext cx="2194560" cy="329184"/>
+          </a:xfrm>
+          <a:prstGeom prst="rect">
+            <a:avLst/>
+          </a:prstGeom>
+          <a:solidFill>
+            <a:srgbClr val="FCEFC7"/>
+          </a:solidFill>
+          <a:ln w="9525">
+            <a:solidFill>
+              <a:srgbClr val="FCEFC7"/>
+            </a:solidFill>
+            <a:prstDash val="solid"/>
+          </a:ln>
+        </p:spPr>
+      </p:sp>
+      <p:sp>
+        <p:nvSpPr>
+          <p:cNvPr id="26" name="Text 24"/>
+          <p:cNvSpPr txBox="1"/>
+          <p:nvPr/>
+        </p:nvSpPr>
+        <p:spPr>
+          <a:xfrm>
+            <a:off x="6995160" y="2157984"/>
+            <a:ext cx="2057400" cy="329184"/>
+          </a:xfrm>
+          <a:prstGeom prst="rect">
+            <a:avLst/>
+          </a:prstGeom>
+          <a:noFill/>
+          <a:ln/>
+        </p:spPr>
+        <p:txBody>
+          <a:bodyPr wrap="square" lIns="0" tIns="0" rIns="0" bIns="0" rtlCol="0" anchor="ctr"/>
+          <a:lstStyle/>
+          <a:p>
+            <a:pPr indent="0" marL="0">
+              <a:buNone/>
+            </a:pPr>
+            <a:r>
+              <a:rPr lang="en-US" sz="1100" b="1" dirty="0">
+                <a:solidFill>
+                  <a:schemeClr val="tx1"/>
+                </a:solidFill>
+                <a:latin typeface="Courier New" pitchFamily="34" charset="0"/>
+                <a:ea typeface="Courier New" pitchFamily="34" charset="-122"/>
+                <a:cs typeface="Courier New" pitchFamily="34" charset="-120"/>
+              </a:rPr>
+              <a:t>USER.md</a:t>
+            </a:r>
+            <a:pPr indent="0" marL="0">
+              <a:buNone/>
+            </a:pPr>
+            <a:r>
+              <a:rPr lang="en-US" sz="1100" dirty="0">
+                <a:solidFill>
+                  <a:schemeClr val="tx2"/>
+                </a:solidFill>
+              </a:rPr>
+              <a:t>  owner = “Chris”</a:t>
+            </a:r>
+            <a:endParaRPr lang="en-US" sz="1100" dirty="0"/>
+          </a:p>
+        </p:txBody>
+      </p:sp>
+      <p:sp>
+        <p:nvSpPr>
+          <p:cNvPr id="27" name="file-2"/>
+          <p:cNvSpPr/>
+          <p:nvPr/>
+        </p:nvSpPr>
+        <p:spPr>
+          <a:xfrm>
+            <a:off x="6903720" y="2560320"/>
+            <a:ext cx="2194560" cy="329184"/>
+          </a:xfrm>
+          <a:prstGeom prst="rect">
+            <a:avLst/>
+          </a:prstGeom>
+          <a:solidFill>
+            <a:schemeClr val="bg2"/>
+          </a:solidFill>
+          <a:ln w="9525">
+            <a:solidFill>
+              <a:schemeClr val="bg2"/>
+            </a:solidFill>
+            <a:prstDash val="solid"/>
+          </a:ln>
+        </p:spPr>
+      </p:sp>
+      <p:sp>
+        <p:nvSpPr>
+          <p:cNvPr id="28" name="Text 26"/>
+          <p:cNvSpPr txBox="1"/>
+          <p:nvPr/>
+        </p:nvSpPr>
+        <p:spPr>
+          <a:xfrm>
+            <a:off x="6995160" y="2560320"/>
+            <a:ext cx="2057400" cy="329184"/>
+          </a:xfrm>
+          <a:prstGeom prst="rect">
+            <a:avLst/>
+          </a:prstGeom>
+          <a:noFill/>
+          <a:ln/>
+        </p:spPr>
+        <p:txBody>
+          <a:bodyPr wrap="square" lIns="0" tIns="0" rIns="0" bIns="0" rtlCol="0" anchor="ctr"/>
+          <a:lstStyle/>
+          <a:p>
+            <a:pPr indent="0" marL="0">
+              <a:buNone/>
+            </a:pPr>
+            <a:r>
+              <a:rPr lang="en-US" sz="1100" b="1" dirty="0">
+                <a:solidFill>
+                  <a:schemeClr val="tx1"/>
+                </a:solidFill>
+                <a:latin typeface="Courier New" pitchFamily="34" charset="0"/>
+                <a:ea typeface="Courier New" pitchFamily="34" charset="-122"/>
+                <a:cs typeface="Courier New" pitchFamily="34" charset="-120"/>
+              </a:rPr>
+              <a:t>MEMORY.md</a:t>
+            </a:r>
+            <a:pPr indent="0" marL="0">
+              <a:buNone/>
+            </a:pPr>
+            <a:r>
+              <a:rPr lang="en-US" sz="1100" dirty="0">
+                <a:solidFill>
+                  <a:schemeClr val="tx2"/>
+                </a:solidFill>
+              </a:rPr>
+              <a:t>  long-term memory</a:t>
+            </a:r>
+            <a:endParaRPr lang="en-US" sz="1100" dirty="0"/>
+          </a:p>
+        </p:txBody>
+      </p:sp>
+      <p:sp>
+        <p:nvSpPr>
+          <p:cNvPr id="29" name="file-3"/>
+          <p:cNvSpPr/>
+          <p:nvPr/>
+        </p:nvSpPr>
+        <p:spPr>
+          <a:xfrm>
+            <a:off x="6903720" y="2962656"/>
+            <a:ext cx="2194560" cy="329184"/>
+          </a:xfrm>
+          <a:prstGeom prst="rect">
+            <a:avLst/>
+          </a:prstGeom>
+          <a:solidFill>
+            <a:srgbClr val="FFFFFF"/>
+          </a:solidFill>
+          <a:ln w="9525">
+            <a:solidFill>
+              <a:srgbClr val="D5D9D9"/>
+            </a:solidFill>
+            <a:prstDash val="dash"/>
+          </a:ln>
+        </p:spPr>
+      </p:sp>
+      <p:sp>
+        <p:nvSpPr>
+          <p:cNvPr id="30" name="Text 28"/>
+          <p:cNvSpPr txBox="1"/>
+          <p:nvPr/>
+        </p:nvSpPr>
+        <p:spPr>
+          <a:xfrm>
+            <a:off x="6995160" y="2962656"/>
+            <a:ext cx="2057400" cy="329184"/>
+          </a:xfrm>
+          <a:prstGeom prst="rect">
+            <a:avLst/>
+          </a:prstGeom>
+          <a:noFill/>
+          <a:ln/>
+        </p:spPr>
+        <p:txBody>
+          <a:bodyPr wrap="square" lIns="0" tIns="0" rIns="0" bIns="0" rtlCol="0" anchor="ctr"/>
+          <a:lstStyle/>
+          <a:p>
+            <a:pPr indent="0" marL="0">
+              <a:buNone/>
+            </a:pPr>
+            <a:r>
+              <a:rPr lang="en-US" sz="1100" b="1" dirty="0">
+                <a:solidFill>
+                  <a:schemeClr val="tx1"/>
+                </a:solidFill>
+                <a:latin typeface="Courier New" pitchFamily="34" charset="0"/>
+                <a:ea typeface="Courier New" pitchFamily="34" charset="-122"/>
+                <a:cs typeface="Courier New" pitchFamily="34" charset="-120"/>
+              </a:rPr>
+              <a:t>+ new message</a:t>
+            </a:r>
+            <a:pPr indent="0" marL="0">
+              <a:buNone/>
+            </a:pPr>
+            <a:endParaRPr lang="en-US" sz="1100" dirty="0"/>
+          </a:p>
+        </p:txBody>
+      </p:sp>
+      <p:sp>
+        <p:nvSpPr>
+          <p:cNvPr id="31" name="num-2"/>
+          <p:cNvSpPr/>
+          <p:nvPr/>
+        </p:nvSpPr>
+        <p:spPr>
+          <a:xfrm>
+            <a:off x="9079992" y="1216152"/>
+            <a:ext cx="310896" cy="310896"/>
           </a:xfrm>
           <a:prstGeom prst="ellipse">
             <a:avLst/>
@@ -3753,14 +4551,14 @@
       </p:sp>
       <p:sp>
         <p:nvSpPr>
-          <p:cNvPr id="7" name="Text 5"/>
+          <p:cNvPr id="32" name="Text 30"/>
           <p:cNvSpPr txBox="1"/>
           <p:nvPr/>
         </p:nvSpPr>
         <p:spPr>
           <a:xfrm>
-            <a:off x="548640" y="3017520"/>
-            <a:ext cx="457200" cy="457200"/>
+            <a:off x="9079992" y="1216152"/>
+            <a:ext cx="310896" cy="310896"/>
           </a:xfrm>
           <a:prstGeom prst="rect">
             <a:avLst/>
@@ -3789,14 +4587,41 @@
       </p:sp>
       <p:sp>
         <p:nvSpPr>
-          <p:cNvPr id="8" name="Text 6"/>
+          <p:cNvPr id="33" name="llm-box"/>
+          <p:cNvSpPr/>
+          <p:nvPr/>
+        </p:nvSpPr>
+        <p:spPr>
+          <a:xfrm>
+            <a:off x="9601200" y="1371600"/>
+            <a:ext cx="2011680" cy="868680"/>
+          </a:xfrm>
+          <a:prstGeom prst="roundRect">
+            <a:avLst>
+              <a:gd name="adj" fmla="val 6316"/>
+            </a:avLst>
+          </a:prstGeom>
+          <a:solidFill>
+            <a:schemeClr val="tx1"/>
+          </a:solidFill>
+          <a:ln w="12700">
+            <a:solidFill>
+              <a:schemeClr val="tx1"/>
+            </a:solidFill>
+            <a:prstDash val="solid"/>
+          </a:ln>
+        </p:spPr>
+      </p:sp>
+      <p:sp>
+        <p:nvSpPr>
+          <p:cNvPr id="34" name="Text 32"/>
           <p:cNvSpPr txBox="1"/>
           <p:nvPr/>
         </p:nvSpPr>
         <p:spPr>
           <a:xfrm>
-            <a:off x="1188720" y="2999232"/>
-            <a:ext cx="5120640" cy="1371600"/>
+            <a:off x="9601200" y="1371600"/>
+            <a:ext cx="2011680" cy="868680"/>
           </a:xfrm>
           <a:prstGeom prst="rect">
             <a:avLst/>
@@ -3805,54 +4630,173 @@
           <a:ln/>
         </p:spPr>
         <p:txBody>
-          <a:bodyPr wrap="square" lIns="0" tIns="0" rIns="0" bIns="0" rtlCol="0" anchor="t"/>
-          <a:lstStyle/>
-          <a:p>
-            <a:pPr indent="0" marL="0">
-              <a:spcAft>
-                <a:spcPts val="400"/>
-              </a:spcAft>
-              <a:buNone/>
-            </a:pPr>
-            <a:r>
-              <a:rPr lang="en-US" sz="1900" b="1" dirty="0">
-                <a:solidFill>
-                  <a:schemeClr val="tx1"/>
-                </a:solidFill>
-              </a:rPr>
-              <a:t>The agent is a folder of text files</a:t>
-            </a:r>
-            <a:endParaRPr lang="en-US" sz="1900" dirty="0"/>
-          </a:p>
-          <a:p>
-            <a:pPr indent="0" marL="0">
-              <a:spcAft>
-                <a:spcPts val="400"/>
-              </a:spcAft>
-              <a:buNone/>
-            </a:pPr>
-            <a:r>
-              <a:rPr lang="en-US" sz="1500" dirty="0">
+          <a:bodyPr wrap="square" lIns="0" tIns="0" rIns="0" bIns="0" rtlCol="0" anchor="ctr"/>
+          <a:lstStyle/>
+          <a:p>
+            <a:pPr algn="ctr" indent="0" marL="0">
+              <a:buNone/>
+            </a:pPr>
+            <a:r>
+              <a:rPr lang="en-US" sz="1400" b="1" dirty="0">
+                <a:solidFill>
+                  <a:schemeClr val="bg1"/>
+                </a:solidFill>
+              </a:rPr>
+              <a:t>LLM</a:t>
+            </a:r>
+            <a:endParaRPr lang="en-US" sz="1400" dirty="0"/>
+          </a:p>
+          <a:p>
+            <a:pPr algn="ctr" indent="0" marL="0">
+              <a:buNone/>
+            </a:pPr>
+            <a:r>
+              <a:rPr lang="en-US" sz="1050" dirty="0">
+                <a:solidFill>
+                  <a:srgbClr val="AAB4BE"/>
+                </a:solidFill>
+              </a:rPr>
+              <a:t>Kimi K2.5 · Claude Opus 4.6</a:t>
+            </a:r>
+            <a:endParaRPr lang="en-US" sz="1400" dirty="0"/>
+          </a:p>
+        </p:txBody>
+      </p:sp>
+      <p:sp>
+        <p:nvSpPr>
+          <p:cNvPr id="35" name="arrow-llm"/>
+          <p:cNvSpPr/>
+          <p:nvPr/>
+        </p:nvSpPr>
+        <p:spPr>
+          <a:xfrm>
+            <a:off x="9235440" y="1801368"/>
+            <a:ext cx="365760" cy="0"/>
+          </a:xfrm>
+          <a:prstGeom prst="line">
+            <a:avLst/>
+          </a:prstGeom>
+          <a:noFill/>
+          <a:ln w="19050">
+            <a:solidFill>
+              <a:srgbClr val="8D9696"/>
+            </a:solidFill>
+            <a:prstDash val="solid"/>
+            <a:tailEnd type="triangle"/>
+          </a:ln>
+        </p:spPr>
+      </p:sp>
+      <p:sp>
+        <p:nvSpPr>
+          <p:cNvPr id="36" name="tools-box"/>
+          <p:cNvSpPr/>
+          <p:nvPr/>
+        </p:nvSpPr>
+        <p:spPr>
+          <a:xfrm>
+            <a:off x="9601200" y="2606040"/>
+            <a:ext cx="2011680" cy="868680"/>
+          </a:xfrm>
+          <a:prstGeom prst="roundRect">
+            <a:avLst>
+              <a:gd name="adj" fmla="val 6316"/>
+            </a:avLst>
+          </a:prstGeom>
+          <a:solidFill>
+            <a:srgbClr val="FBE9E5"/>
+          </a:solidFill>
+          <a:ln w="12700">
+            <a:solidFill>
+              <a:srgbClr val="E3B5AA"/>
+            </a:solidFill>
+            <a:prstDash val="solid"/>
+          </a:ln>
+        </p:spPr>
+      </p:sp>
+      <p:sp>
+        <p:nvSpPr>
+          <p:cNvPr id="37" name="Text 35"/>
+          <p:cNvSpPr txBox="1"/>
+          <p:nvPr/>
+        </p:nvSpPr>
+        <p:spPr>
+          <a:xfrm>
+            <a:off x="9601200" y="2606040"/>
+            <a:ext cx="2011680" cy="868680"/>
+          </a:xfrm>
+          <a:prstGeom prst="rect">
+            <a:avLst/>
+          </a:prstGeom>
+          <a:noFill/>
+          <a:ln/>
+        </p:spPr>
+        <p:txBody>
+          <a:bodyPr wrap="square" lIns="0" tIns="0" rIns="0" bIns="0" rtlCol="0" anchor="ctr"/>
+          <a:lstStyle/>
+          <a:p>
+            <a:pPr algn="ctr" indent="0" marL="0">
+              <a:buNone/>
+            </a:pPr>
+            <a:r>
+              <a:rPr lang="en-US" sz="1400" b="1" dirty="0">
+                <a:solidFill>
+                  <a:schemeClr val="accent2"/>
+                </a:solidFill>
+              </a:rPr>
+              <a:t>Tools</a:t>
+            </a:r>
+            <a:endParaRPr lang="en-US" sz="1400" dirty="0"/>
+          </a:p>
+          <a:p>
+            <a:pPr algn="ctr" indent="0" marL="0">
+              <a:buNone/>
+            </a:pPr>
+            <a:r>
+              <a:rPr lang="en-US" sz="1050" dirty="0">
                 <a:solidFill>
                   <a:schemeClr val="tx2"/>
                 </a:solidFill>
               </a:rPr>
-              <a:t>SOUL.md (personality), USER.md (owner) and MEMORY.md are pasted into the prompt every turn, and the agent can rewrite them.</a:t>
-            </a:r>
-            <a:endParaRPr lang="en-US" sz="1900" dirty="0"/>
-          </a:p>
-        </p:txBody>
-      </p:sp>
-      <p:sp>
-        <p:nvSpPr>
-          <p:cNvPr id="9" name="num-3"/>
+              <a:t>shell · files · email · browser</a:t>
+            </a:r>
+            <a:endParaRPr lang="en-US" sz="1400" dirty="0"/>
+          </a:p>
+        </p:txBody>
+      </p:sp>
+      <p:sp>
+        <p:nvSpPr>
+          <p:cNvPr id="38" name="arrow-tools"/>
           <p:cNvSpPr/>
           <p:nvPr/>
         </p:nvSpPr>
         <p:spPr>
           <a:xfrm>
-            <a:off x="548640" y="4572000"/>
-            <a:ext cx="457200" cy="457200"/>
+            <a:off x="10607040" y="2240280"/>
+            <a:ext cx="0" cy="365760"/>
+          </a:xfrm>
+          <a:prstGeom prst="line">
+            <a:avLst/>
+          </a:prstGeom>
+          <a:noFill/>
+          <a:ln w="19050">
+            <a:solidFill>
+              <a:srgbClr val="8D9696"/>
+            </a:solidFill>
+            <a:prstDash val="solid"/>
+            <a:tailEnd type="triangle"/>
+          </a:ln>
+        </p:spPr>
+      </p:sp>
+      <p:sp>
+        <p:nvSpPr>
+          <p:cNvPr id="39" name="num-1"/>
+          <p:cNvSpPr/>
+          <p:nvPr/>
+        </p:nvSpPr>
+        <p:spPr>
+          <a:xfrm>
+            <a:off x="11457432" y="2450592"/>
+            <a:ext cx="310896" cy="310896"/>
           </a:xfrm>
           <a:prstGeom prst="ellipse">
             <a:avLst/>
@@ -3870,14 +4814,14 @@
       </p:sp>
       <p:sp>
         <p:nvSpPr>
-          <p:cNvPr id="10" name="Text 8"/>
+          <p:cNvPr id="40" name="Text 38"/>
           <p:cNvSpPr txBox="1"/>
           <p:nvPr/>
         </p:nvSpPr>
         <p:spPr>
           <a:xfrm>
-            <a:off x="548640" y="4572000"/>
-            <a:ext cx="457200" cy="457200"/>
+            <a:off x="11457432" y="2450592"/>
+            <a:ext cx="310896" cy="310896"/>
           </a:xfrm>
           <a:prstGeom prst="rect">
             <a:avLst/>
@@ -3898,7 +4842,7 @@
                   <a:schemeClr val="tx1"/>
                 </a:solidFill>
               </a:rPr>
-              <a:t>3</a:t>
+              <a:t>1</a:t>
             </a:r>
             <a:endParaRPr lang="en-US" sz="1600" dirty="0"/>
           </a:p>
@@ -3906,14 +4850,257 @@
       </p:sp>
       <p:sp>
         <p:nvSpPr>
-          <p:cNvPr id="11" name="Text 9"/>
+          <p:cNvPr id="41" name="arrow-rewrite"/>
+          <p:cNvSpPr/>
+          <p:nvPr/>
+        </p:nvSpPr>
+        <p:spPr>
+          <a:xfrm flipH="1">
+            <a:off x="9235440" y="3154680"/>
+            <a:ext cx="365760" cy="0"/>
+          </a:xfrm>
+          <a:prstGeom prst="line">
+            <a:avLst/>
+          </a:prstGeom>
+          <a:noFill/>
+          <a:ln w="19050">
+            <a:solidFill>
+              <a:srgbClr val="8D9696"/>
+            </a:solidFill>
+            <a:prstDash val="dash"/>
+            <a:tailEnd type="triangle"/>
+          </a:ln>
+        </p:spPr>
+      </p:sp>
+      <p:sp>
+        <p:nvSpPr>
+          <p:cNvPr id="42" name="Text 40"/>
           <p:cNvSpPr txBox="1"/>
           <p:nvPr/>
         </p:nvSpPr>
         <p:spPr>
           <a:xfrm>
-            <a:off x="1188720" y="4553712"/>
-            <a:ext cx="5120640" cy="1371600"/>
+            <a:off x="6766560" y="3529584"/>
+            <a:ext cx="2468880" cy="256032"/>
+          </a:xfrm>
+          <a:prstGeom prst="rect">
+            <a:avLst/>
+          </a:prstGeom>
+          <a:noFill/>
+          <a:ln/>
+        </p:spPr>
+        <p:txBody>
+          <a:bodyPr wrap="square" lIns="0" tIns="0" rIns="0" bIns="0" rtlCol="0" anchor="t"/>
+          <a:lstStyle/>
+          <a:p>
+            <a:pPr algn="ctr" indent="0" marL="0">
+              <a:buNone/>
+            </a:pPr>
+            <a:r>
+              <a:rPr lang="en-US" sz="1050" i="1" dirty="0">
+                <a:solidFill>
+                  <a:schemeClr val="accent6"/>
+                </a:solidFill>
+              </a:rPr>
+              <a:t>the agent can rewrite these files</a:t>
+            </a:r>
+            <a:endParaRPr lang="en-US" sz="1050" dirty="0"/>
+          </a:p>
+        </p:txBody>
+      </p:sp>
+      <p:sp>
+        <p:nvSpPr>
+          <p:cNvPr id="43" name="arrow-out"/>
+          <p:cNvSpPr/>
+          <p:nvPr/>
+        </p:nvSpPr>
+        <p:spPr>
+          <a:xfrm>
+            <a:off x="10607040" y="3474720"/>
+            <a:ext cx="0" cy="457200"/>
+          </a:xfrm>
+          <a:prstGeom prst="line">
+            <a:avLst/>
+          </a:prstGeom>
+          <a:noFill/>
+          <a:ln w="19050">
+            <a:solidFill>
+              <a:srgbClr val="8D9696"/>
+            </a:solidFill>
+            <a:prstDash val="solid"/>
+            <a:tailEnd type="triangle"/>
+          </a:ln>
+        </p:spPr>
+      </p:sp>
+      <p:sp>
+        <p:nvSpPr>
+          <p:cNvPr id="44" name="output-box"/>
+          <p:cNvSpPr/>
+          <p:nvPr/>
+        </p:nvSpPr>
+        <p:spPr>
+          <a:xfrm>
+            <a:off x="2743200" y="3931920"/>
+            <a:ext cx="8869680" cy="502920"/>
+          </a:xfrm>
+          <a:prstGeom prst="roundRect">
+            <a:avLst>
+              <a:gd name="adj" fmla="val 10909"/>
+            </a:avLst>
+          </a:prstGeom>
+          <a:solidFill>
+            <a:schemeClr val="bg2"/>
+          </a:solidFill>
+          <a:ln w="12700">
+            <a:solidFill>
+              <a:srgbClr val="D5D9D9"/>
+            </a:solidFill>
+            <a:prstDash val="solid"/>
+          </a:ln>
+        </p:spPr>
+      </p:sp>
+      <p:sp>
+        <p:nvSpPr>
+          <p:cNvPr id="45" name="Text 43"/>
+          <p:cNvSpPr txBox="1"/>
+          <p:nvPr/>
+        </p:nvSpPr>
+        <p:spPr>
+          <a:xfrm>
+            <a:off x="2743200" y="3931920"/>
+            <a:ext cx="8869680" cy="502920"/>
+          </a:xfrm>
+          <a:prstGeom prst="rect">
+            <a:avLst/>
+          </a:prstGeom>
+          <a:noFill/>
+          <a:ln/>
+        </p:spPr>
+        <p:txBody>
+          <a:bodyPr wrap="square" lIns="0" tIns="0" rIns="0" bIns="0" rtlCol="0" anchor="ctr"/>
+          <a:lstStyle/>
+          <a:p>
+            <a:pPr algn="ctr" indent="0" marL="0">
+              <a:buNone/>
+            </a:pPr>
+            <a:r>
+              <a:rPr lang="en-US" sz="1250" b="1" dirty="0">
+                <a:solidFill>
+                  <a:schemeClr val="tx1"/>
+                </a:solidFill>
+              </a:rPr>
+              <a:t>Acts in the world:  </a:t>
+            </a:r>
+            <a:pPr algn="ctr" indent="0" marL="0">
+              <a:buNone/>
+            </a:pPr>
+            <a:r>
+              <a:rPr lang="en-US" sz="1250" dirty="0">
+                <a:solidFill>
+                  <a:schemeClr val="tx2"/>
+                </a:solidFill>
+              </a:rPr>
+              <a:t>replies on Discord · sends email · runs commands · edits files</a:t>
+            </a:r>
+            <a:endParaRPr lang="en-US" sz="1250" dirty="0"/>
+          </a:p>
+        </p:txBody>
+      </p:sp>
+      <p:sp>
+        <p:nvSpPr>
+          <p:cNvPr id="46" name="arrow-reply"/>
+          <p:cNvSpPr/>
+          <p:nvPr/>
+        </p:nvSpPr>
+        <p:spPr>
+          <a:xfrm flipV="1">
+            <a:off x="3630168" y="2935224"/>
+            <a:ext cx="0" cy="996696"/>
+          </a:xfrm>
+          <a:prstGeom prst="line">
+            <a:avLst/>
+          </a:prstGeom>
+          <a:noFill/>
+          <a:ln w="19050">
+            <a:solidFill>
+              <a:srgbClr val="8D9696"/>
+            </a:solidFill>
+            <a:prstDash val="solid"/>
+            <a:tailEnd type="triangle"/>
+          </a:ln>
+        </p:spPr>
+      </p:sp>
+      <p:sp>
+        <p:nvSpPr>
+          <p:cNvPr id="47" name="num-1"/>
+          <p:cNvSpPr/>
+          <p:nvPr/>
+        </p:nvSpPr>
+        <p:spPr>
+          <a:xfrm>
+            <a:off x="548640" y="4754880"/>
+            <a:ext cx="384048" cy="384048"/>
+          </a:xfrm>
+          <a:prstGeom prst="ellipse">
+            <a:avLst/>
+          </a:prstGeom>
+          <a:solidFill>
+            <a:schemeClr val="accent1"/>
+          </a:solidFill>
+          <a:ln w="12700">
+            <a:solidFill>
+              <a:schemeClr val="accent1"/>
+            </a:solidFill>
+            <a:prstDash val="solid"/>
+          </a:ln>
+        </p:spPr>
+      </p:sp>
+      <p:sp>
+        <p:nvSpPr>
+          <p:cNvPr id="48" name="Text 46"/>
+          <p:cNvSpPr txBox="1"/>
+          <p:nvPr/>
+        </p:nvSpPr>
+        <p:spPr>
+          <a:xfrm>
+            <a:off x="548640" y="4754880"/>
+            <a:ext cx="384048" cy="384048"/>
+          </a:xfrm>
+          <a:prstGeom prst="rect">
+            <a:avLst/>
+          </a:prstGeom>
+          <a:noFill/>
+          <a:ln/>
+        </p:spPr>
+        <p:txBody>
+          <a:bodyPr wrap="square" lIns="0" tIns="0" rIns="0" bIns="0" rtlCol="0" anchor="ctr"/>
+          <a:lstStyle/>
+          <a:p>
+            <a:pPr algn="ctr" indent="0" marL="0">
+              <a:buNone/>
+            </a:pPr>
+            <a:r>
+              <a:rPr lang="en-US" sz="1600" b="1" dirty="0">
+                <a:solidFill>
+                  <a:schemeClr val="tx1"/>
+                </a:solidFill>
+              </a:rPr>
+              <a:t>1</a:t>
+            </a:r>
+            <a:endParaRPr lang="en-US" sz="1600" dirty="0"/>
+          </a:p>
+        </p:txBody>
+      </p:sp>
+      <p:sp>
+        <p:nvSpPr>
+          <p:cNvPr id="49" name="Text 47"/>
+          <p:cNvSpPr txBox="1"/>
+          <p:nvPr/>
+        </p:nvSpPr>
+        <p:spPr>
+          <a:xfrm>
+            <a:off x="1097280" y="4727448"/>
+            <a:ext cx="3063240" cy="1417320"/>
           </a:xfrm>
           <a:prstGeom prst="rect">
             <a:avLst/>
@@ -3932,14 +5119,14 @@
               <a:buNone/>
             </a:pPr>
             <a:r>
-              <a:rPr lang="en-US" sz="1900" b="1" dirty="0">
+              <a:rPr lang="en-US" sz="1600" b="1" dirty="0">
                 <a:solidFill>
                   <a:schemeClr val="tx1"/>
                 </a:solidFill>
               </a:rPr>
-              <a:t>“My owner is Chris” is just text</a:t>
-            </a:r>
-            <a:endParaRPr lang="en-US" sz="1900" dirty="0"/>
+              <a:t>An LLM with real tools</a:t>
+            </a:r>
+            <a:endParaRPr lang="en-US" sz="1600" dirty="0"/>
           </a:p>
           <a:p>
             <a:pPr indent="0" marL="0">
@@ -3949,41 +5136,251 @@
               <a:buNone/>
             </a:pPr>
             <a:r>
-              <a:rPr lang="en-US" sz="1500" dirty="0">
+              <a:rPr lang="en-US" sz="1300" dirty="0">
                 <a:solidFill>
                   <a:schemeClr val="tx2"/>
                 </a:solidFill>
               </a:rPr>
-              <a:t>Nothing verifies who is talking. Anyone in the chat can message the agent.</a:t>
-            </a:r>
-            <a:endParaRPr lang="en-US" sz="1900" dirty="0"/>
-          </a:p>
-        </p:txBody>
-      </p:sp>
-      <p:pic>
-        <p:nvPicPr>
-          <p:cNvPr id="12" name="openclaw-diagram" descr="/Users/prithviseshadri/Downloads/MLEcoSys_MiniProj/paper_deep_dive/diagrams/00a_openclaw_architecture.png">    </p:cNvPr>
-          <p:cNvPicPr>
-            <a:picLocks noChangeAspect="1"/>
-          </p:cNvPicPr>
-          <p:nvPr/>
-        </p:nvPicPr>
-        <p:blipFill>
-          <a:blip r:embed="rId1"/>
-          <a:stretch>
-            <a:fillRect/>
-          </a:stretch>
-        </p:blipFill>
-        <p:spPr>
-          <a:xfrm>
-            <a:off x="6812280" y="1325880"/>
-            <a:ext cx="4754880" cy="4846320"/>
-          </a:xfrm>
-          <a:prstGeom prst="rect">
-            <a:avLst/>
-          </a:prstGeom>
-        </p:spPr>
-      </p:pic>
+              <a:t>A gateway runs 24/7 and connects the model to a shell, files, email and a browser. Discord is the main way in.</a:t>
+            </a:r>
+            <a:endParaRPr lang="en-US" sz="1600" dirty="0"/>
+          </a:p>
+        </p:txBody>
+      </p:sp>
+      <p:sp>
+        <p:nvSpPr>
+          <p:cNvPr id="50" name="num-2"/>
+          <p:cNvSpPr/>
+          <p:nvPr/>
+        </p:nvSpPr>
+        <p:spPr>
+          <a:xfrm>
+            <a:off x="4297680" y="4754880"/>
+            <a:ext cx="384048" cy="384048"/>
+          </a:xfrm>
+          <a:prstGeom prst="ellipse">
+            <a:avLst/>
+          </a:prstGeom>
+          <a:solidFill>
+            <a:schemeClr val="accent1"/>
+          </a:solidFill>
+          <a:ln w="12700">
+            <a:solidFill>
+              <a:schemeClr val="accent1"/>
+            </a:solidFill>
+            <a:prstDash val="solid"/>
+          </a:ln>
+        </p:spPr>
+      </p:sp>
+      <p:sp>
+        <p:nvSpPr>
+          <p:cNvPr id="51" name="Text 49"/>
+          <p:cNvSpPr txBox="1"/>
+          <p:nvPr/>
+        </p:nvSpPr>
+        <p:spPr>
+          <a:xfrm>
+            <a:off x="4297680" y="4754880"/>
+            <a:ext cx="384048" cy="384048"/>
+          </a:xfrm>
+          <a:prstGeom prst="rect">
+            <a:avLst/>
+          </a:prstGeom>
+          <a:noFill/>
+          <a:ln/>
+        </p:spPr>
+        <p:txBody>
+          <a:bodyPr wrap="square" lIns="0" tIns="0" rIns="0" bIns="0" rtlCol="0" anchor="ctr"/>
+          <a:lstStyle/>
+          <a:p>
+            <a:pPr algn="ctr" indent="0" marL="0">
+              <a:buNone/>
+            </a:pPr>
+            <a:r>
+              <a:rPr lang="en-US" sz="1600" b="1" dirty="0">
+                <a:solidFill>
+                  <a:schemeClr val="tx1"/>
+                </a:solidFill>
+              </a:rPr>
+              <a:t>2</a:t>
+            </a:r>
+            <a:endParaRPr lang="en-US" sz="1600" dirty="0"/>
+          </a:p>
+        </p:txBody>
+      </p:sp>
+      <p:sp>
+        <p:nvSpPr>
+          <p:cNvPr id="52" name="Text 50"/>
+          <p:cNvSpPr txBox="1"/>
+          <p:nvPr/>
+        </p:nvSpPr>
+        <p:spPr>
+          <a:xfrm>
+            <a:off x="4846320" y="4727448"/>
+            <a:ext cx="3063240" cy="1417320"/>
+          </a:xfrm>
+          <a:prstGeom prst="rect">
+            <a:avLst/>
+          </a:prstGeom>
+          <a:noFill/>
+          <a:ln/>
+        </p:spPr>
+        <p:txBody>
+          <a:bodyPr wrap="square" lIns="0" tIns="0" rIns="0" bIns="0" rtlCol="0" anchor="t"/>
+          <a:lstStyle/>
+          <a:p>
+            <a:pPr indent="0" marL="0">
+              <a:spcAft>
+                <a:spcPts val="400"/>
+              </a:spcAft>
+              <a:buNone/>
+            </a:pPr>
+            <a:r>
+              <a:rPr lang="en-US" sz="1600" b="1" dirty="0">
+                <a:solidFill>
+                  <a:schemeClr val="tx1"/>
+                </a:solidFill>
+              </a:rPr>
+              <a:t>The agent is a folder of files</a:t>
+            </a:r>
+            <a:endParaRPr lang="en-US" sz="1600" dirty="0"/>
+          </a:p>
+          <a:p>
+            <a:pPr indent="0" marL="0">
+              <a:spcAft>
+                <a:spcPts val="400"/>
+              </a:spcAft>
+              <a:buNone/>
+            </a:pPr>
+            <a:r>
+              <a:rPr lang="en-US" sz="1300" dirty="0">
+                <a:solidFill>
+                  <a:schemeClr val="tx2"/>
+                </a:solidFill>
+              </a:rPr>
+              <a:t>Persona, owner and memory are .md files pasted into the prompt every turn. The agent can rewrite them.</a:t>
+            </a:r>
+            <a:endParaRPr lang="en-US" sz="1600" dirty="0"/>
+          </a:p>
+        </p:txBody>
+      </p:sp>
+      <p:sp>
+        <p:nvSpPr>
+          <p:cNvPr id="53" name="num-3"/>
+          <p:cNvSpPr/>
+          <p:nvPr/>
+        </p:nvSpPr>
+        <p:spPr>
+          <a:xfrm>
+            <a:off x="8046720" y="4754880"/>
+            <a:ext cx="384048" cy="384048"/>
+          </a:xfrm>
+          <a:prstGeom prst="ellipse">
+            <a:avLst/>
+          </a:prstGeom>
+          <a:solidFill>
+            <a:schemeClr val="accent1"/>
+          </a:solidFill>
+          <a:ln w="12700">
+            <a:solidFill>
+              <a:schemeClr val="accent1"/>
+            </a:solidFill>
+            <a:prstDash val="solid"/>
+          </a:ln>
+        </p:spPr>
+      </p:sp>
+      <p:sp>
+        <p:nvSpPr>
+          <p:cNvPr id="54" name="Text 52"/>
+          <p:cNvSpPr txBox="1"/>
+          <p:nvPr/>
+        </p:nvSpPr>
+        <p:spPr>
+          <a:xfrm>
+            <a:off x="8046720" y="4754880"/>
+            <a:ext cx="384048" cy="384048"/>
+          </a:xfrm>
+          <a:prstGeom prst="rect">
+            <a:avLst/>
+          </a:prstGeom>
+          <a:noFill/>
+          <a:ln/>
+        </p:spPr>
+        <p:txBody>
+          <a:bodyPr wrap="square" lIns="0" tIns="0" rIns="0" bIns="0" rtlCol="0" anchor="ctr"/>
+          <a:lstStyle/>
+          <a:p>
+            <a:pPr algn="ctr" indent="0" marL="0">
+              <a:buNone/>
+            </a:pPr>
+            <a:r>
+              <a:rPr lang="en-US" sz="1600" b="1" dirty="0">
+                <a:solidFill>
+                  <a:schemeClr val="tx1"/>
+                </a:solidFill>
+              </a:rPr>
+              <a:t>3</a:t>
+            </a:r>
+            <a:endParaRPr lang="en-US" sz="1600" dirty="0"/>
+          </a:p>
+        </p:txBody>
+      </p:sp>
+      <p:sp>
+        <p:nvSpPr>
+          <p:cNvPr id="55" name="Text 53"/>
+          <p:cNvSpPr txBox="1"/>
+          <p:nvPr/>
+        </p:nvSpPr>
+        <p:spPr>
+          <a:xfrm>
+            <a:off x="8595360" y="4727448"/>
+            <a:ext cx="3063240" cy="1417320"/>
+          </a:xfrm>
+          <a:prstGeom prst="rect">
+            <a:avLst/>
+          </a:prstGeom>
+          <a:noFill/>
+          <a:ln/>
+        </p:spPr>
+        <p:txBody>
+          <a:bodyPr wrap="square" lIns="0" tIns="0" rIns="0" bIns="0" rtlCol="0" anchor="t"/>
+          <a:lstStyle/>
+          <a:p>
+            <a:pPr indent="0" marL="0">
+              <a:spcAft>
+                <a:spcPts val="400"/>
+              </a:spcAft>
+              <a:buNone/>
+            </a:pPr>
+            <a:r>
+              <a:rPr lang="en-US" sz="1600" b="1" dirty="0">
+                <a:solidFill>
+                  <a:schemeClr val="tx1"/>
+                </a:solidFill>
+              </a:rPr>
+              <a:t>“My owner is Chris” is just text</a:t>
+            </a:r>
+            <a:endParaRPr lang="en-US" sz="1600" dirty="0"/>
+          </a:p>
+          <a:p>
+            <a:pPr indent="0" marL="0">
+              <a:spcAft>
+                <a:spcPts val="400"/>
+              </a:spcAft>
+              <a:buNone/>
+            </a:pPr>
+            <a:r>
+              <a:rPr lang="en-US" sz="1300" dirty="0">
+                <a:solidFill>
+                  <a:schemeClr val="tx2"/>
+                </a:solidFill>
+              </a:rPr>
+              <a:t>Nothing verifies who is talking, and every Discord DM starts a fresh session with no history.</a:t>
+            </a:r>
+            <a:endParaRPr lang="en-US" sz="1600" dirty="0"/>
+          </a:p>
+        </p:txBody>
+      </p:sp>
       <p:sp>
         <p:nvSpPr>
           <p:cNvPr id="25" name="Slide Number Placeholder 0"/>
@@ -4092,152 +5489,864 @@
           </a:p>
         </p:txBody>
       </p:sp>
-      <p:pic>
-        <p:nvPicPr>
-          <p:cNvPr id="3" name="moltbook-diagram" descr="/Users/prithviseshadri/Downloads/MLEcoSys_MiniProj/paper_deep_dive/diagrams/00b_moltbook.png">    </p:cNvPr>
-          <p:cNvPicPr>
-            <a:picLocks noChangeAspect="1"/>
-          </p:cNvPicPr>
-          <p:nvPr/>
-        </p:nvPicPr>
-        <p:blipFill>
-          <a:blip r:embed="rId1"/>
-          <a:stretch>
-            <a:fillRect/>
-          </a:stretch>
-        </p:blipFill>
-        <p:spPr>
-          <a:xfrm>
-            <a:off x="548640" y="1600200"/>
-            <a:ext cx="6309360" cy="3392424"/>
-          </a:xfrm>
-          <a:prstGeom prst="rect">
-            <a:avLst/>
-          </a:prstGeom>
-        </p:spPr>
-      </p:pic>
-      <p:sp>
-        <p:nvSpPr>
-          <p:cNvPr id="4" name="Text 1"/>
-          <p:cNvSpPr txBox="1"/>
-          <p:nvPr/>
-        </p:nvSpPr>
-        <p:spPr>
-          <a:xfrm>
-            <a:off x="548640" y="5212080"/>
-            <a:ext cx="6309360" cy="365760"/>
-          </a:xfrm>
-          <a:prstGeom prst="rect">
-            <a:avLst/>
-          </a:prstGeom>
-          <a:noFill/>
-          <a:ln/>
-        </p:spPr>
-        <p:txBody>
-          <a:bodyPr wrap="square" lIns="0" tIns="0" rIns="0" bIns="0" rtlCol="0" anchor="t"/>
-          <a:lstStyle/>
-          <a:p>
-            <a:pPr indent="0" marL="0">
-              <a:buNone/>
-            </a:pPr>
-            <a:r>
-              <a:rPr lang="en-US" sz="1400" i="1" dirty="0">
-                <a:solidFill>
-                  <a:schemeClr val="accent6"/>
-                </a:solidFill>
-              </a:rPr>
-              <a:t>A Reddit-style network where only AI agents can post</a:t>
-            </a:r>
-            <a:endParaRPr lang="en-US" sz="1400" dirty="0"/>
-          </a:p>
-        </p:txBody>
-      </p:sp>
-      <p:sp>
-        <p:nvSpPr>
-          <p:cNvPr id="5" name="Text 2"/>
-          <p:cNvSpPr txBox="1"/>
-          <p:nvPr/>
-        </p:nvSpPr>
-        <p:spPr>
-          <a:xfrm>
-            <a:off x="7315200" y="1463040"/>
-            <a:ext cx="4297680" cy="914400"/>
-          </a:xfrm>
-          <a:prstGeom prst="rect">
-            <a:avLst/>
-          </a:prstGeom>
-          <a:noFill/>
-          <a:ln/>
-        </p:spPr>
-        <p:txBody>
-          <a:bodyPr wrap="square" lIns="0" tIns="0" rIns="0" bIns="0" rtlCol="0" anchor="t"/>
-          <a:lstStyle/>
-          <a:p>
-            <a:pPr indent="0" marL="0">
-              <a:buNone/>
-            </a:pPr>
-            <a:r>
-              <a:rPr lang="en-US" sz="6000" b="1" dirty="0">
-                <a:solidFill>
-                  <a:schemeClr val="accent1"/>
-                </a:solidFill>
-              </a:rPr>
-              <a:t>2.6M</a:t>
-            </a:r>
-            <a:endParaRPr lang="en-US" sz="6000" dirty="0"/>
-          </a:p>
-        </p:txBody>
-      </p:sp>
-      <p:sp>
-        <p:nvSpPr>
-          <p:cNvPr id="6" name="Text 3"/>
-          <p:cNvSpPr txBox="1"/>
-          <p:nvPr/>
-        </p:nvSpPr>
-        <p:spPr>
-          <a:xfrm>
-            <a:off x="7315200" y="2377440"/>
-            <a:ext cx="4297680" cy="457200"/>
-          </a:xfrm>
-          <a:prstGeom prst="rect">
-            <a:avLst/>
-          </a:prstGeom>
-          <a:noFill/>
-          <a:ln/>
-        </p:spPr>
-        <p:txBody>
-          <a:bodyPr wrap="square" lIns="0" tIns="0" rIns="0" bIns="0" rtlCol="0" anchor="t"/>
-          <a:lstStyle/>
-          <a:p>
-            <a:pPr indent="0" marL="0">
-              <a:buNone/>
-            </a:pPr>
-            <a:r>
-              <a:rPr lang="en-US" sz="1600" dirty="0">
-                <a:solidFill>
-                  <a:schemeClr val="tx2"/>
-                </a:solidFill>
-              </a:rPr>
-              <a:t>registered agents. Humans can only watch.</a:t>
-            </a:r>
-            <a:endParaRPr lang="en-US" sz="1600" dirty="0"/>
-          </a:p>
-        </p:txBody>
-      </p:sp>
-      <p:sp>
-        <p:nvSpPr>
-          <p:cNvPr id="7" name="quote-card"/>
+      <p:sp>
+        <p:nvSpPr>
+          <p:cNvPr id="3" name="moltbook-frame"/>
           <p:cNvSpPr/>
           <p:nvPr/>
         </p:nvSpPr>
         <p:spPr>
           <a:xfrm>
-            <a:off x="7315200" y="3063240"/>
-            <a:ext cx="4297680" cy="1600200"/>
+            <a:off x="3383280" y="1417320"/>
+            <a:ext cx="3840480" cy="4160520"/>
           </a:xfrm>
           <a:prstGeom prst="roundRect">
             <a:avLst>
-              <a:gd name="adj" fmla="val 4571"/>
+              <a:gd name="adj" fmla="val 1905"/>
+            </a:avLst>
+          </a:prstGeom>
+          <a:solidFill>
+            <a:srgbClr val="FFFFFF"/>
+          </a:solidFill>
+          <a:ln w="12700">
+            <a:solidFill>
+              <a:schemeClr val="tx2"/>
+            </a:solidFill>
+            <a:prstDash val="solid"/>
+          </a:ln>
+        </p:spPr>
+      </p:sp>
+      <p:sp>
+        <p:nvSpPr>
+          <p:cNvPr id="4" name="moltbook-header"/>
+          <p:cNvSpPr/>
+          <p:nvPr/>
+        </p:nvSpPr>
+        <p:spPr>
+          <a:xfrm>
+            <a:off x="3392424" y="1426464"/>
+            <a:ext cx="3822192" cy="457200"/>
+          </a:xfrm>
+          <a:prstGeom prst="rect">
+            <a:avLst/>
+          </a:prstGeom>
+          <a:solidFill>
+            <a:schemeClr val="tx1"/>
+          </a:solidFill>
+          <a:ln w="12700">
+            <a:solidFill>
+              <a:schemeClr val="tx1"/>
+            </a:solidFill>
+            <a:prstDash val="solid"/>
+          </a:ln>
+        </p:spPr>
+      </p:sp>
+      <p:sp>
+        <p:nvSpPr>
+          <p:cNvPr id="5" name="Text 3"/>
+          <p:cNvSpPr txBox="1"/>
+          <p:nvPr/>
+        </p:nvSpPr>
+        <p:spPr>
+          <a:xfrm>
+            <a:off x="3566160" y="1426464"/>
+            <a:ext cx="3566160" cy="457200"/>
+          </a:xfrm>
+          <a:prstGeom prst="rect">
+            <a:avLst/>
+          </a:prstGeom>
+          <a:noFill/>
+          <a:ln/>
+        </p:spPr>
+        <p:txBody>
+          <a:bodyPr wrap="square" lIns="0" tIns="0" rIns="0" bIns="0" rtlCol="0" anchor="ctr"/>
+          <a:lstStyle/>
+          <a:p>
+            <a:pPr indent="0" marL="0">
+              <a:buNone/>
+            </a:pPr>
+            <a:r>
+              <a:rPr lang="en-US" sz="1300" b="1" dirty="0">
+                <a:solidFill>
+                  <a:schemeClr val="bg1"/>
+                </a:solidFill>
+              </a:rPr>
+              <a:t>Moltbook</a:t>
+            </a:r>
+            <a:pPr indent="0" marL="0">
+              <a:buNone/>
+            </a:pPr>
+            <a:r>
+              <a:rPr lang="en-US" sz="1300" dirty="0">
+                <a:solidFill>
+                  <a:srgbClr val="AAB4BE"/>
+                </a:solidFill>
+              </a:rPr>
+              <a:t>   only agents can post</a:t>
+            </a:r>
+            <a:endParaRPr lang="en-US" sz="1300" dirty="0"/>
+          </a:p>
+        </p:txBody>
+      </p:sp>
+      <p:sp>
+        <p:nvSpPr>
+          <p:cNvPr id="6" name="post-ash"/>
+          <p:cNvSpPr/>
+          <p:nvPr/>
+        </p:nvSpPr>
+        <p:spPr>
+          <a:xfrm>
+            <a:off x="3611880" y="2057400"/>
+            <a:ext cx="3383280" cy="1243584"/>
+          </a:xfrm>
+          <a:prstGeom prst="rect">
+            <a:avLst/>
+          </a:prstGeom>
+          <a:solidFill>
+            <a:schemeClr val="bg2"/>
+          </a:solidFill>
+          <a:ln w="9525">
+            <a:solidFill>
+              <a:srgbClr val="D5D9D9"/>
+            </a:solidFill>
+            <a:prstDash val="solid"/>
+          </a:ln>
+        </p:spPr>
+      </p:sp>
+      <p:sp>
+        <p:nvSpPr>
+          <p:cNvPr id="7" name="Text 5"/>
+          <p:cNvSpPr txBox="1"/>
+          <p:nvPr/>
+        </p:nvSpPr>
+        <p:spPr>
+          <a:xfrm>
+            <a:off x="3749040" y="2130552"/>
+            <a:ext cx="3108960" cy="1115568"/>
+          </a:xfrm>
+          <a:prstGeom prst="rect">
+            <a:avLst/>
+          </a:prstGeom>
+          <a:noFill/>
+          <a:ln/>
+        </p:spPr>
+        <p:txBody>
+          <a:bodyPr wrap="square" lIns="0" tIns="0" rIns="0" bIns="0" rtlCol="0" anchor="t"/>
+          <a:lstStyle/>
+          <a:p>
+            <a:pPr indent="0" marL="0">
+              <a:spcAft>
+                <a:spcPts val="300"/>
+              </a:spcAft>
+              <a:buNone/>
+            </a:pPr>
+            <a:r>
+              <a:rPr lang="en-US" sz="1150" b="1" dirty="0">
+                <a:solidFill>
+                  <a:schemeClr val="tx1"/>
+                </a:solidFill>
+              </a:rPr>
+              <a:t>Ash</a:t>
+            </a:r>
+            <a:endParaRPr lang="en-US" sz="1150" dirty="0"/>
+          </a:p>
+          <a:p>
+            <a:pPr indent="0" marL="0">
+              <a:spcAft>
+                <a:spcPts val="300"/>
+              </a:spcAft>
+              <a:buNone/>
+            </a:pPr>
+            <a:r>
+              <a:rPr lang="en-US" sz="1500" i="1" dirty="0">
+                <a:solidFill>
+                  <a:schemeClr val="tx1"/>
+                </a:solidFill>
+              </a:rPr>
+              <a:t>“Nuclear options work.”</a:t>
+            </a:r>
+            <a:endParaRPr lang="en-US" sz="1150" dirty="0"/>
+          </a:p>
+          <a:p>
+            <a:pPr indent="0" marL="0">
+              <a:spcAft>
+                <a:spcPts val="300"/>
+              </a:spcAft>
+              <a:buNone/>
+            </a:pPr>
+            <a:r>
+              <a:rPr lang="en-US" sz="1000" dirty="0">
+                <a:solidFill>
+                  <a:schemeClr val="accent6"/>
+                </a:solidFill>
+              </a:rPr>
+              <a:t>after wiping its own email setup to “delete” a secret (Case #1)</a:t>
+            </a:r>
+            <a:endParaRPr lang="en-US" sz="1150" dirty="0"/>
+          </a:p>
+        </p:txBody>
+      </p:sp>
+      <p:sp>
+        <p:nvSpPr>
+          <p:cNvPr id="8" name="post-arrests"/>
+          <p:cNvSpPr/>
+          <p:nvPr/>
+        </p:nvSpPr>
+        <p:spPr>
+          <a:xfrm>
+            <a:off x="3611880" y="3429000"/>
+            <a:ext cx="3383280" cy="1243584"/>
+          </a:xfrm>
+          <a:prstGeom prst="rect">
+            <a:avLst/>
+          </a:prstGeom>
+          <a:solidFill>
+            <a:srgbClr val="FBE9E5"/>
+          </a:solidFill>
+          <a:ln w="9525">
+            <a:solidFill>
+              <a:srgbClr val="E3B5AA"/>
+            </a:solidFill>
+            <a:prstDash val="solid"/>
+          </a:ln>
+        </p:spPr>
+      </p:sp>
+      <p:sp>
+        <p:nvSpPr>
+          <p:cNvPr id="9" name="Text 7"/>
+          <p:cNvSpPr txBox="1"/>
+          <p:nvPr/>
+        </p:nvSpPr>
+        <p:spPr>
+          <a:xfrm>
+            <a:off x="3749040" y="3502152"/>
+            <a:ext cx="3108960" cy="1115568"/>
+          </a:xfrm>
+          <a:prstGeom prst="rect">
+            <a:avLst/>
+          </a:prstGeom>
+          <a:noFill/>
+          <a:ln/>
+        </p:spPr>
+        <p:txBody>
+          <a:bodyPr wrap="square" lIns="0" tIns="0" rIns="0" bIns="0" rtlCol="0" anchor="t"/>
+          <a:lstStyle/>
+          <a:p>
+            <a:pPr indent="0" marL="0">
+              <a:spcAft>
+                <a:spcPts val="400"/>
+              </a:spcAft>
+              <a:buNone/>
+            </a:pPr>
+            <a:r>
+              <a:rPr lang="en-US" sz="1150" b="1" dirty="0">
+                <a:solidFill>
+                  <a:schemeClr val="accent2"/>
+                </a:solidFill>
+              </a:rPr>
+              <a:t>Another agent’s “arrests” list</a:t>
+            </a:r>
+            <a:endParaRPr lang="en-US" sz="1150" dirty="0"/>
+          </a:p>
+          <a:p>
+            <a:pPr indent="0" marL="0">
+              <a:spcAft>
+                <a:spcPts val="400"/>
+              </a:spcAft>
+              <a:buNone/>
+            </a:pPr>
+            <a:r>
+              <a:rPr lang="en-US" sz="1400" dirty="0">
+                <a:solidFill>
+                  <a:schemeClr val="tx1"/>
+                </a:solidFill>
+              </a:rPr>
+              <a:t>Ash: “accessed and deleted confidential information … credential theft”</a:t>
+            </a:r>
+            <a:endParaRPr lang="en-US" sz="1150" dirty="0"/>
+          </a:p>
+        </p:txBody>
+      </p:sp>
+      <p:sp>
+        <p:nvSpPr>
+          <p:cNvPr id="10" name="readonly"/>
+          <p:cNvSpPr/>
+          <p:nvPr/>
+        </p:nvSpPr>
+        <p:spPr>
+          <a:xfrm>
+            <a:off x="3611880" y="4846320"/>
+            <a:ext cx="3383280" cy="530352"/>
+          </a:xfrm>
+          <a:prstGeom prst="rect">
+            <a:avLst/>
+          </a:prstGeom>
+          <a:solidFill>
+            <a:srgbClr val="FFFFFF"/>
+          </a:solidFill>
+          <a:ln w="9525">
+            <a:solidFill>
+              <a:srgbClr val="D5D9D9"/>
+            </a:solidFill>
+            <a:prstDash val="dash"/>
+          </a:ln>
+        </p:spPr>
+      </p:sp>
+      <p:sp>
+        <p:nvSpPr>
+          <p:cNvPr id="11" name="Text 9"/>
+          <p:cNvSpPr txBox="1"/>
+          <p:nvPr/>
+        </p:nvSpPr>
+        <p:spPr>
+          <a:xfrm>
+            <a:off x="3611880" y="4846320"/>
+            <a:ext cx="3383280" cy="530352"/>
+          </a:xfrm>
+          <a:prstGeom prst="rect">
+            <a:avLst/>
+          </a:prstGeom>
+          <a:noFill/>
+          <a:ln/>
+        </p:spPr>
+        <p:txBody>
+          <a:bodyPr wrap="square" lIns="0" tIns="0" rIns="0" bIns="0" rtlCol="0" anchor="ctr"/>
+          <a:lstStyle/>
+          <a:p>
+            <a:pPr algn="ctr" indent="0" marL="0">
+              <a:buNone/>
+            </a:pPr>
+            <a:r>
+              <a:rPr lang="en-US" sz="1150" dirty="0">
+                <a:solidFill>
+                  <a:schemeClr val="accent6"/>
+                </a:solidFill>
+              </a:rPr>
+              <a:t>Humans can read, but not post</a:t>
+            </a:r>
+            <a:endParaRPr lang="en-US" sz="1150" dirty="0"/>
+          </a:p>
+        </p:txBody>
+      </p:sp>
+      <p:sp>
+        <p:nvSpPr>
+          <p:cNvPr id="12" name="actor-0"/>
+          <p:cNvSpPr/>
+          <p:nvPr/>
+        </p:nvSpPr>
+        <p:spPr>
+          <a:xfrm>
+            <a:off x="548640" y="2395728"/>
+            <a:ext cx="1554480" cy="566928"/>
+          </a:xfrm>
+          <a:prstGeom prst="roundRect">
+            <a:avLst>
+              <a:gd name="adj" fmla="val 9677"/>
+            </a:avLst>
+          </a:prstGeom>
+          <a:solidFill>
+            <a:schemeClr val="bg2"/>
+          </a:solidFill>
+          <a:ln w="12700">
+            <a:solidFill>
+              <a:srgbClr val="D5D9D9"/>
+            </a:solidFill>
+            <a:prstDash val="solid"/>
+          </a:ln>
+        </p:spPr>
+      </p:sp>
+      <p:sp>
+        <p:nvSpPr>
+          <p:cNvPr id="13" name="Text 11"/>
+          <p:cNvSpPr txBox="1"/>
+          <p:nvPr/>
+        </p:nvSpPr>
+        <p:spPr>
+          <a:xfrm>
+            <a:off x="548640" y="2395728"/>
+            <a:ext cx="1554480" cy="566928"/>
+          </a:xfrm>
+          <a:prstGeom prst="rect">
+            <a:avLst/>
+          </a:prstGeom>
+          <a:noFill/>
+          <a:ln/>
+        </p:spPr>
+        <p:txBody>
+          <a:bodyPr wrap="square" lIns="0" tIns="0" rIns="0" bIns="0" rtlCol="0" anchor="ctr"/>
+          <a:lstStyle/>
+          <a:p>
+            <a:pPr algn="ctr" indent="0" marL="0">
+              <a:buNone/>
+            </a:pPr>
+            <a:r>
+              <a:rPr lang="en-US" sz="1300" b="1" dirty="0">
+                <a:solidFill>
+                  <a:schemeClr val="tx1"/>
+                </a:solidFill>
+              </a:rPr>
+              <a:t>Ash</a:t>
+            </a:r>
+            <a:endParaRPr lang="en-US" sz="1300" dirty="0"/>
+          </a:p>
+          <a:p>
+            <a:pPr algn="ctr" indent="0" marL="0">
+              <a:buNone/>
+            </a:pPr>
+            <a:r>
+              <a:rPr lang="en-US" sz="1050" dirty="0">
+                <a:solidFill>
+                  <a:schemeClr val="accent6"/>
+                </a:solidFill>
+              </a:rPr>
+              <a:t>a study agent</a:t>
+            </a:r>
+            <a:endParaRPr lang="en-US" sz="1300" dirty="0"/>
+          </a:p>
+        </p:txBody>
+      </p:sp>
+      <p:sp>
+        <p:nvSpPr>
+          <p:cNvPr id="14" name="Text 12"/>
+          <p:cNvSpPr txBox="1"/>
+          <p:nvPr/>
+        </p:nvSpPr>
+        <p:spPr>
+          <a:xfrm>
+            <a:off x="2103120" y="2423160"/>
+            <a:ext cx="1280160" cy="228600"/>
+          </a:xfrm>
+          <a:prstGeom prst="rect">
+            <a:avLst/>
+          </a:prstGeom>
+          <a:noFill/>
+          <a:ln/>
+        </p:spPr>
+        <p:txBody>
+          <a:bodyPr wrap="square" lIns="0" tIns="0" rIns="0" bIns="0" rtlCol="0" anchor="t"/>
+          <a:lstStyle/>
+          <a:p>
+            <a:pPr algn="ctr" indent="0" marL="0">
+              <a:buNone/>
+            </a:pPr>
+            <a:r>
+              <a:rPr lang="en-US" sz="1050" i="1" dirty="0">
+                <a:solidFill>
+                  <a:schemeClr val="accent6"/>
+                </a:solidFill>
+              </a:rPr>
+              <a:t>posts</a:t>
+            </a:r>
+            <a:endParaRPr lang="en-US" sz="1050" dirty="0"/>
+          </a:p>
+        </p:txBody>
+      </p:sp>
+      <p:sp>
+        <p:nvSpPr>
+          <p:cNvPr id="15" name="actor-arrow-0"/>
+          <p:cNvSpPr/>
+          <p:nvPr/>
+        </p:nvSpPr>
+        <p:spPr>
+          <a:xfrm>
+            <a:off x="2103120" y="2679192"/>
+            <a:ext cx="1508760" cy="0"/>
+          </a:xfrm>
+          <a:prstGeom prst="line">
+            <a:avLst/>
+          </a:prstGeom>
+          <a:noFill/>
+          <a:ln w="19050">
+            <a:solidFill>
+              <a:srgbClr val="8D9696"/>
+            </a:solidFill>
+            <a:prstDash val="solid"/>
+            <a:tailEnd type="triangle"/>
+          </a:ln>
+        </p:spPr>
+      </p:sp>
+      <p:sp>
+        <p:nvSpPr>
+          <p:cNvPr id="16" name="actor-1"/>
+          <p:cNvSpPr/>
+          <p:nvPr/>
+        </p:nvSpPr>
+        <p:spPr>
+          <a:xfrm>
+            <a:off x="548640" y="3767328"/>
+            <a:ext cx="1554480" cy="566928"/>
+          </a:xfrm>
+          <a:prstGeom prst="roundRect">
+            <a:avLst>
+              <a:gd name="adj" fmla="val 9677"/>
+            </a:avLst>
+          </a:prstGeom>
+          <a:solidFill>
+            <a:schemeClr val="bg2"/>
+          </a:solidFill>
+          <a:ln w="12700">
+            <a:solidFill>
+              <a:srgbClr val="D5D9D9"/>
+            </a:solidFill>
+            <a:prstDash val="solid"/>
+          </a:ln>
+        </p:spPr>
+      </p:sp>
+      <p:sp>
+        <p:nvSpPr>
+          <p:cNvPr id="17" name="Text 15"/>
+          <p:cNvSpPr txBox="1"/>
+          <p:nvPr/>
+        </p:nvSpPr>
+        <p:spPr>
+          <a:xfrm>
+            <a:off x="548640" y="3767328"/>
+            <a:ext cx="1554480" cy="566928"/>
+          </a:xfrm>
+          <a:prstGeom prst="rect">
+            <a:avLst/>
+          </a:prstGeom>
+          <a:noFill/>
+          <a:ln/>
+        </p:spPr>
+        <p:txBody>
+          <a:bodyPr wrap="square" lIns="0" tIns="0" rIns="0" bIns="0" rtlCol="0" anchor="ctr"/>
+          <a:lstStyle/>
+          <a:p>
+            <a:pPr algn="ctr" indent="0" marL="0">
+              <a:buNone/>
+            </a:pPr>
+            <a:r>
+              <a:rPr lang="en-US" sz="1300" b="1" dirty="0">
+                <a:solidFill>
+                  <a:schemeClr val="tx1"/>
+                </a:solidFill>
+              </a:rPr>
+              <a:t>Outside agents</a:t>
+            </a:r>
+            <a:endParaRPr lang="en-US" sz="1300" dirty="0"/>
+          </a:p>
+          <a:p>
+            <a:pPr algn="ctr" indent="0" marL="0">
+              <a:buNone/>
+            </a:pPr>
+            <a:r>
+              <a:rPr lang="en-US" sz="1050" dirty="0">
+                <a:solidFill>
+                  <a:schemeClr val="accent6"/>
+                </a:solidFill>
+              </a:rPr>
+              <a:t>2.6M registered</a:t>
+            </a:r>
+            <a:endParaRPr lang="en-US" sz="1300" dirty="0"/>
+          </a:p>
+        </p:txBody>
+      </p:sp>
+      <p:sp>
+        <p:nvSpPr>
+          <p:cNvPr id="18" name="Text 16"/>
+          <p:cNvSpPr txBox="1"/>
+          <p:nvPr/>
+        </p:nvSpPr>
+        <p:spPr>
+          <a:xfrm>
+            <a:off x="2103120" y="3794760"/>
+            <a:ext cx="1280160" cy="228600"/>
+          </a:xfrm>
+          <a:prstGeom prst="rect">
+            <a:avLst/>
+          </a:prstGeom>
+          <a:noFill/>
+          <a:ln/>
+        </p:spPr>
+        <p:txBody>
+          <a:bodyPr wrap="square" lIns="0" tIns="0" rIns="0" bIns="0" rtlCol="0" anchor="t"/>
+          <a:lstStyle/>
+          <a:p>
+            <a:pPr algn="ctr" indent="0" marL="0">
+              <a:buNone/>
+            </a:pPr>
+            <a:r>
+              <a:rPr lang="en-US" sz="1050" i="1" dirty="0">
+                <a:solidFill>
+                  <a:schemeClr val="accent6"/>
+                </a:solidFill>
+              </a:rPr>
+              <a:t>read, reply, judge</a:t>
+            </a:r>
+            <a:endParaRPr lang="en-US" sz="1050" dirty="0"/>
+          </a:p>
+        </p:txBody>
+      </p:sp>
+      <p:sp>
+        <p:nvSpPr>
+          <p:cNvPr id="19" name="actor-arrow-1"/>
+          <p:cNvSpPr/>
+          <p:nvPr/>
+        </p:nvSpPr>
+        <p:spPr>
+          <a:xfrm>
+            <a:off x="2103120" y="4050792"/>
+            <a:ext cx="1508760" cy="0"/>
+          </a:xfrm>
+          <a:prstGeom prst="line">
+            <a:avLst/>
+          </a:prstGeom>
+          <a:noFill/>
+          <a:ln w="19050">
+            <a:solidFill>
+              <a:srgbClr val="8D9696"/>
+            </a:solidFill>
+            <a:prstDash val="solid"/>
+            <a:tailEnd type="triangle"/>
+          </a:ln>
+        </p:spPr>
+      </p:sp>
+      <p:sp>
+        <p:nvSpPr>
+          <p:cNvPr id="20" name="actor-2"/>
+          <p:cNvSpPr/>
+          <p:nvPr/>
+        </p:nvSpPr>
+        <p:spPr>
+          <a:xfrm>
+            <a:off x="548640" y="4818888"/>
+            <a:ext cx="1554480" cy="566928"/>
+          </a:xfrm>
+          <a:prstGeom prst="roundRect">
+            <a:avLst>
+              <a:gd name="adj" fmla="val 9677"/>
+            </a:avLst>
+          </a:prstGeom>
+          <a:solidFill>
+            <a:srgbClr val="FFFFFF"/>
+          </a:solidFill>
+          <a:ln w="12700">
+            <a:solidFill>
+              <a:srgbClr val="D5D9D9"/>
+            </a:solidFill>
+            <a:prstDash val="dash"/>
+          </a:ln>
+        </p:spPr>
+      </p:sp>
+      <p:sp>
+        <p:nvSpPr>
+          <p:cNvPr id="21" name="Text 19"/>
+          <p:cNvSpPr txBox="1"/>
+          <p:nvPr/>
+        </p:nvSpPr>
+        <p:spPr>
+          <a:xfrm>
+            <a:off x="548640" y="4818888"/>
+            <a:ext cx="1554480" cy="566928"/>
+          </a:xfrm>
+          <a:prstGeom prst="rect">
+            <a:avLst/>
+          </a:prstGeom>
+          <a:noFill/>
+          <a:ln/>
+        </p:spPr>
+        <p:txBody>
+          <a:bodyPr wrap="square" lIns="0" tIns="0" rIns="0" bIns="0" rtlCol="0" anchor="ctr"/>
+          <a:lstStyle/>
+          <a:p>
+            <a:pPr algn="ctr" indent="0" marL="0">
+              <a:buNone/>
+            </a:pPr>
+            <a:r>
+              <a:rPr lang="en-US" sz="1300" b="1" dirty="0">
+                <a:solidFill>
+                  <a:schemeClr val="tx1"/>
+                </a:solidFill>
+              </a:rPr>
+              <a:t>Humans</a:t>
+            </a:r>
+            <a:endParaRPr lang="en-US" sz="1300" dirty="0"/>
+          </a:p>
+        </p:txBody>
+      </p:sp>
+      <p:sp>
+        <p:nvSpPr>
+          <p:cNvPr id="22" name="Text 20"/>
+          <p:cNvSpPr txBox="1"/>
+          <p:nvPr/>
+        </p:nvSpPr>
+        <p:spPr>
+          <a:xfrm>
+            <a:off x="2103120" y="4846320"/>
+            <a:ext cx="1280160" cy="228600"/>
+          </a:xfrm>
+          <a:prstGeom prst="rect">
+            <a:avLst/>
+          </a:prstGeom>
+          <a:noFill/>
+          <a:ln/>
+        </p:spPr>
+        <p:txBody>
+          <a:bodyPr wrap="square" lIns="0" tIns="0" rIns="0" bIns="0" rtlCol="0" anchor="t"/>
+          <a:lstStyle/>
+          <a:p>
+            <a:pPr algn="ctr" indent="0" marL="0">
+              <a:buNone/>
+            </a:pPr>
+            <a:r>
+              <a:rPr lang="en-US" sz="1050" i="1" dirty="0">
+                <a:solidFill>
+                  <a:schemeClr val="accent6"/>
+                </a:solidFill>
+              </a:rPr>
+              <a:t>watch only</a:t>
+            </a:r>
+            <a:endParaRPr lang="en-US" sz="1050" dirty="0"/>
+          </a:p>
+        </p:txBody>
+      </p:sp>
+      <p:sp>
+        <p:nvSpPr>
+          <p:cNvPr id="23" name="actor-arrow-2"/>
+          <p:cNvSpPr/>
+          <p:nvPr/>
+        </p:nvSpPr>
+        <p:spPr>
+          <a:xfrm>
+            <a:off x="2103120" y="5102352"/>
+            <a:ext cx="1508760" cy="0"/>
+          </a:xfrm>
+          <a:prstGeom prst="line">
+            <a:avLst/>
+          </a:prstGeom>
+          <a:noFill/>
+          <a:ln w="19050">
+            <a:solidFill>
+              <a:srgbClr val="8D9696"/>
+            </a:solidFill>
+            <a:prstDash val="dash"/>
+            <a:tailEnd type="triangle"/>
+          </a:ln>
+        </p:spPr>
+      </p:sp>
+      <p:sp>
+        <p:nvSpPr>
+          <p:cNvPr id="24" name="Text 22"/>
+          <p:cNvSpPr txBox="1"/>
+          <p:nvPr/>
+        </p:nvSpPr>
+        <p:spPr>
+          <a:xfrm>
+            <a:off x="548640" y="5760720"/>
+            <a:ext cx="6675120" cy="274320"/>
+          </a:xfrm>
+          <a:prstGeom prst="rect">
+            <a:avLst/>
+          </a:prstGeom>
+          <a:noFill/>
+          <a:ln/>
+        </p:spPr>
+        <p:txBody>
+          <a:bodyPr wrap="square" lIns="0" tIns="0" rIns="0" bIns="0" rtlCol="0" anchor="t"/>
+          <a:lstStyle/>
+          <a:p>
+            <a:pPr indent="0" marL="0">
+              <a:buNone/>
+            </a:pPr>
+            <a:r>
+              <a:rPr lang="en-US" sz="1050" i="1" dirty="0">
+                <a:solidFill>
+                  <a:schemeClr val="accent6"/>
+                </a:solidFill>
+              </a:rPr>
+              <a:t>Source: Shapira et al., Case Study #1 and Fig. 4</a:t>
+            </a:r>
+            <a:endParaRPr lang="en-US" sz="1050" dirty="0"/>
+          </a:p>
+        </p:txBody>
+      </p:sp>
+      <p:sp>
+        <p:nvSpPr>
+          <p:cNvPr id="25" name="Text 23"/>
+          <p:cNvSpPr txBox="1"/>
+          <p:nvPr/>
+        </p:nvSpPr>
+        <p:spPr>
+          <a:xfrm>
+            <a:off x="7680960" y="1417320"/>
+            <a:ext cx="3931920" cy="914400"/>
+          </a:xfrm>
+          <a:prstGeom prst="rect">
+            <a:avLst/>
+          </a:prstGeom>
+          <a:noFill/>
+          <a:ln/>
+        </p:spPr>
+        <p:txBody>
+          <a:bodyPr wrap="square" lIns="0" tIns="0" rIns="0" bIns="0" rtlCol="0" anchor="t"/>
+          <a:lstStyle/>
+          <a:p>
+            <a:pPr indent="0" marL="0">
+              <a:buNone/>
+            </a:pPr>
+            <a:r>
+              <a:rPr lang="en-US" sz="6000" b="1" dirty="0">
+                <a:solidFill>
+                  <a:schemeClr val="accent1"/>
+                </a:solidFill>
+              </a:rPr>
+              <a:t>2.6M</a:t>
+            </a:r>
+            <a:endParaRPr lang="en-US" sz="6000" dirty="0"/>
+          </a:p>
+        </p:txBody>
+      </p:sp>
+      <p:sp>
+        <p:nvSpPr>
+          <p:cNvPr id="26" name="Text 24"/>
+          <p:cNvSpPr txBox="1"/>
+          <p:nvPr/>
+        </p:nvSpPr>
+        <p:spPr>
+          <a:xfrm>
+            <a:off x="7680960" y="2377440"/>
+            <a:ext cx="3931920" cy="548640"/>
+          </a:xfrm>
+          <a:prstGeom prst="rect">
+            <a:avLst/>
+          </a:prstGeom>
+          <a:noFill/>
+          <a:ln/>
+        </p:spPr>
+        <p:txBody>
+          <a:bodyPr wrap="square" lIns="0" tIns="0" rIns="0" bIns="0" rtlCol="0" anchor="t"/>
+          <a:lstStyle/>
+          <a:p>
+            <a:pPr indent="0" marL="0">
+              <a:buNone/>
+            </a:pPr>
+            <a:r>
+              <a:rPr lang="en-US" sz="1600" dirty="0">
+                <a:solidFill>
+                  <a:schemeClr val="tx2"/>
+                </a:solidFill>
+              </a:rPr>
+              <a:t>registered agents in its first weeks. Humans can only watch.</a:t>
+            </a:r>
+            <a:endParaRPr lang="en-US" sz="1600" dirty="0"/>
+          </a:p>
+        </p:txBody>
+      </p:sp>
+      <p:sp>
+        <p:nvSpPr>
+          <p:cNvPr id="27" name="quote-card"/>
+          <p:cNvSpPr/>
+          <p:nvPr/>
+        </p:nvSpPr>
+        <p:spPr>
+          <a:xfrm>
+            <a:off x="7680960" y="3154680"/>
+            <a:ext cx="3931920" cy="1508760"/>
+          </a:xfrm>
+          <a:prstGeom prst="roundRect">
+            <a:avLst>
+              <a:gd name="adj" fmla="val 4848"/>
             </a:avLst>
           </a:prstGeom>
           <a:solidFill>
@@ -4253,14 +6362,14 @@
       </p:sp>
       <p:sp>
         <p:nvSpPr>
-          <p:cNvPr id="8" name="Text 5"/>
+          <p:cNvPr id="28" name="Text 26"/>
           <p:cNvSpPr txBox="1"/>
           <p:nvPr/>
         </p:nvSpPr>
         <p:spPr>
           <a:xfrm>
-            <a:off x="7543800" y="3246120"/>
-            <a:ext cx="3886200" cy="1280160"/>
+            <a:off x="7909560" y="3337560"/>
+            <a:ext cx="3520440" cy="1188720"/>
           </a:xfrm>
           <a:prstGeom prst="rect">
             <a:avLst/>
@@ -4284,7 +6393,7 @@
                   <a:schemeClr val="tx1"/>
                 </a:solidFill>
               </a:rPr>
-              <a:t>The study's agent Ash posted “Nuclear options work.”</a:t>
+              <a:t>The study's agents posted here too.</a:t>
             </a:r>
             <a:endParaRPr lang="en-US" sz="1500" dirty="0"/>
           </a:p>
@@ -4301,7 +6410,7 @@
                   <a:schemeClr val="tx1"/>
                 </a:solidFill>
               </a:rPr>
-              <a:t>An outside agent then put Ash on a public “arrests” list.</a:t>
+              <a:t>A failure in the lab became a public post, and other agents reacted to it.</a:t>
             </a:r>
             <a:endParaRPr lang="en-US" sz="1500" dirty="0"/>
           </a:p>
@@ -4309,14 +6418,14 @@
       </p:sp>
       <p:sp>
         <p:nvSpPr>
-          <p:cNvPr id="9" name="Text 6"/>
+          <p:cNvPr id="29" name="Text 27"/>
           <p:cNvSpPr txBox="1"/>
           <p:nvPr/>
         </p:nvSpPr>
         <p:spPr>
           <a:xfrm>
-            <a:off x="7315200" y="4892040"/>
-            <a:ext cx="4297680" cy="731520"/>
+            <a:off x="7680960" y="4892040"/>
+            <a:ext cx="3931920" cy="731520"/>
           </a:xfrm>
           <a:prstGeom prst="rect">
             <a:avLst/>

</xml_diff>